<commit_message>
Refine Aura site visuals, social links, image rendering stability, and update final presentation
</commit_message>
<xml_diff>
--- a/PRC305-Aura-Final-Presentation.pptx
+++ b/PRC305-Aura-Final-Presentation.pptx
@@ -15,15 +15,6 @@
     <p:sldId id="263" r:id="rId14"/>
     <p:sldId id="264" r:id="rId15"/>
     <p:sldId id="265" r:id="rId16"/>
-    <p:sldId id="266" r:id="rId17"/>
-    <p:sldId id="267" r:id="rId18"/>
-    <p:sldId id="268" r:id="rId19"/>
-    <p:sldId id="269" r:id="rId20"/>
-    <p:sldId id="270" r:id="rId21"/>
-    <p:sldId id="271" r:id="rId22"/>
-    <p:sldId id="272" r:id="rId23"/>
-    <p:sldId id="273" r:id="rId24"/>
-    <p:sldId id="274" r:id="rId25"/>
   </p:sldIdLst>
   <p:sldSz cx="12191695" cy="6858000" type="screen4x3"/>
   <p:notesSz cx="6858000" cy="9144000"/>
@@ -3108,14 +3099,188 @@
       <p:grpSpPr/>
       <p:sp>
         <p:nvSpPr>
+          <p:cNvPr id="8" name="Rounded Rectangle 7"/>
+          <p:cNvSpPr/>
+          <p:nvPr/>
+        </p:nvSpPr>
+        <p:spPr>
+          <a:xfrm>
+            <a:off x="975335" y="822960"/>
+            <a:ext cx="10484857" cy="5349240"/>
+          </a:xfrm>
+          <a:prstGeom prst="roundRect">
+            <a:avLst/>
+          </a:prstGeom>
+          <a:solidFill>
+            <a:srgbClr val="313244"/>
+          </a:solidFill>
+          <a:ln w="15240">
+            <a:solidFill>
+              <a:srgbClr val="45475A"/>
+            </a:solidFill>
+          </a:ln>
+        </p:spPr>
+        <p:style>
+          <a:lnRef idx="1">
+            <a:schemeClr val="accent1"/>
+          </a:lnRef>
+          <a:fillRef idx="3">
+            <a:schemeClr val="accent1"/>
+          </a:fillRef>
+          <a:effectRef idx="2">
+            <a:schemeClr val="accent1"/>
+          </a:effectRef>
+          <a:fontRef idx="minor">
+            <a:schemeClr val="lt1"/>
+          </a:fontRef>
+        </p:style>
+        <p:txBody>
+          <a:bodyPr rtlCol="0" anchor="ctr"/>
+          <a:lstStyle/>
+          <a:p>
+            <a:pPr algn="ctr"/>
+          </a:p>
+        </p:txBody>
+      </p:sp>
+      <p:sp>
+        <p:nvSpPr>
+          <p:cNvPr id="7" name="Rectangle 6"/>
+          <p:cNvSpPr/>
+          <p:nvPr/>
+        </p:nvSpPr>
+        <p:spPr>
+          <a:xfrm>
+            <a:off x="487667" y="548640"/>
+            <a:ext cx="73150" cy="5760720"/>
+          </a:xfrm>
+          <a:prstGeom prst="rect">
+            <a:avLst/>
+          </a:prstGeom>
+          <a:solidFill>
+            <a:srgbClr val="CBA6F7"/>
+          </a:solidFill>
+          <a:ln>
+            <a:noFill/>
+          </a:ln>
+        </p:spPr>
+        <p:style>
+          <a:lnRef idx="1">
+            <a:schemeClr val="accent1"/>
+          </a:lnRef>
+          <a:fillRef idx="3">
+            <a:schemeClr val="accent1"/>
+          </a:fillRef>
+          <a:effectRef idx="2">
+            <a:schemeClr val="accent1"/>
+          </a:effectRef>
+          <a:fontRef idx="minor">
+            <a:schemeClr val="lt1"/>
+          </a:fontRef>
+        </p:style>
+        <p:txBody>
+          <a:bodyPr rtlCol="0" anchor="ctr"/>
+          <a:lstStyle/>
+          <a:p>
+            <a:pPr algn="ctr"/>
+          </a:p>
+        </p:txBody>
+      </p:sp>
+      <p:sp>
+        <p:nvSpPr>
+          <p:cNvPr id="6" name="Rectangle 5"/>
+          <p:cNvSpPr/>
+          <p:nvPr/>
+        </p:nvSpPr>
+        <p:spPr>
+          <a:xfrm>
+            <a:off x="0" y="0"/>
+            <a:ext cx="12191695" cy="1234440"/>
+          </a:xfrm>
+          <a:prstGeom prst="rect">
+            <a:avLst/>
+          </a:prstGeom>
+          <a:solidFill>
+            <a:srgbClr val="162343"/>
+          </a:solidFill>
+          <a:ln>
+            <a:noFill/>
+          </a:ln>
+        </p:spPr>
+        <p:style>
+          <a:lnRef idx="1">
+            <a:schemeClr val="accent1"/>
+          </a:lnRef>
+          <a:fillRef idx="3">
+            <a:schemeClr val="accent1"/>
+          </a:fillRef>
+          <a:effectRef idx="2">
+            <a:schemeClr val="accent1"/>
+          </a:effectRef>
+          <a:fontRef idx="minor">
+            <a:schemeClr val="lt1"/>
+          </a:fontRef>
+        </p:style>
+        <p:txBody>
+          <a:bodyPr rtlCol="0" anchor="ctr"/>
+          <a:lstStyle/>
+          <a:p>
+            <a:pPr algn="ctr"/>
+          </a:p>
+        </p:txBody>
+      </p:sp>
+      <p:sp>
+        <p:nvSpPr>
+          <p:cNvPr id="5" name="Rectangle 4"/>
+          <p:cNvSpPr/>
+          <p:nvPr/>
+        </p:nvSpPr>
+        <p:spPr>
+          <a:xfrm>
+            <a:off x="0" y="0"/>
+            <a:ext cx="12191695" cy="6858000"/>
+          </a:xfrm>
+          <a:prstGeom prst="rect">
+            <a:avLst/>
+          </a:prstGeom>
+          <a:solidFill>
+            <a:srgbClr val="1E1E2E"/>
+          </a:solidFill>
+          <a:ln>
+            <a:noFill/>
+          </a:ln>
+        </p:spPr>
+        <p:style>
+          <a:lnRef idx="1">
+            <a:schemeClr val="accent1"/>
+          </a:lnRef>
+          <a:fillRef idx="3">
+            <a:schemeClr val="accent1"/>
+          </a:fillRef>
+          <a:effectRef idx="2">
+            <a:schemeClr val="accent1"/>
+          </a:effectRef>
+          <a:fontRef idx="minor">
+            <a:schemeClr val="lt1"/>
+          </a:fontRef>
+        </p:style>
+        <p:txBody>
+          <a:bodyPr rtlCol="0" anchor="ctr"/>
+          <a:lstStyle/>
+          <a:p>
+            <a:pPr algn="ctr"/>
+          </a:p>
+        </p:txBody>
+      </p:sp>
+      <p:sp>
+        <p:nvSpPr>
           <p:cNvPr id="2" name="Rectangle 1"/>
           <p:cNvSpPr/>
           <p:nvPr/>
         </p:nvSpPr>
         <p:spPr>
           <a:xfrm>
-            <a:off x="0" y="0"/>
-            <a:ext cx="12191695" cy="109728"/>
+            <a:off x="1341086" y="1028700"/>
+            <a:ext cx="9753356" cy="109728"/>
           </a:xfrm>
           <a:prstGeom prst="rect">
             <a:avLst/>
@@ -3142,10 +3307,20 @@
           </a:fontRef>
         </p:style>
         <p:txBody>
-          <a:bodyPr rtlCol="0" anchor="ctr"/>
-          <a:lstStyle/>
-          <a:p>
-            <a:pPr algn="ctr"/>
+          <a:bodyPr rtlCol="0" anchor="ctr" wrap="square"/>
+          <a:lstStyle/>
+          <a:p>
+            <a:pPr algn="ctr">
+              <a:lnSpc>
+                <a:spcPct val="125000"/>
+              </a:lnSpc>
+              <a:spcBef>
+                <a:spcPts val="0"/>
+              </a:spcBef>
+              <a:spcAft>
+                <a:spcPts val="800"/>
+              </a:spcAft>
+            </a:pPr>
           </a:p>
         </p:txBody>
       </p:sp>
@@ -3157,8 +3332,8 @@
         </p:nvSpPr>
         <p:spPr>
           <a:xfrm>
-            <a:off x="685800" y="914400"/>
-            <a:ext cx="10789920" cy="2926080"/>
+            <a:off x="1341086" y="914400"/>
+            <a:ext cx="9753356" cy="2926080"/>
           </a:xfrm>
           <a:prstGeom prst="rect">
             <a:avLst/>
@@ -3172,6 +3347,15 @@
           <a:lstStyle/>
           <a:p>
             <a:pPr>
+              <a:lnSpc>
+                <a:spcPct val="125000"/>
+              </a:lnSpc>
+              <a:spcBef>
+                <a:spcPts val="0"/>
+              </a:spcBef>
+              <a:spcAft>
+                <a:spcPts val="800"/>
+              </a:spcAft>
               <a:defRPr sz="1800" b="0">
                 <a:solidFill>
                   <a:srgbClr val="4B5563"/>
@@ -3179,14 +3363,26 @@
               </a:defRPr>
             </a:pPr>
             <a:r>
+              <a:rPr b="1" sz="3800">
+                <a:solidFill>
+                  <a:srgbClr val="EEF2FF"/>
+                </a:solidFill>
+                <a:latin typeface="JetBrains Mono"/>
+              </a:rPr>
               <a:t>PRC 305: Web Design &amp; Content Management Systems for PR</a:t>
             </a:r>
           </a:p>
           <a:p>
             <a:pPr>
+              <a:lnSpc>
+                <a:spcPct val="125000"/>
+              </a:lnSpc>
               <a:spcBef>
-                <a:spcPts val="1000"/>
+                <a:spcPts val="0"/>
               </a:spcBef>
+              <a:spcAft>
+                <a:spcPts val="800"/>
+              </a:spcAft>
               <a:defRPr sz="3800" b="1">
                 <a:solidFill>
                   <a:srgbClr val="060D18"/>
@@ -3194,14 +3390,26 @@
               </a:defRPr>
             </a:pPr>
             <a:r>
-              <a:t>Final Project Presentation</a:t>
+              <a:rPr sz="1600">
+                <a:solidFill>
+                  <a:srgbClr val="CDD6F4"/>
+                </a:solidFill>
+                <a:latin typeface="JetBrains Mono"/>
+              </a:rPr>
+              <a:t>• Final Project Presentation</a:t>
             </a:r>
           </a:p>
           <a:p>
             <a:pPr>
+              <a:lnSpc>
+                <a:spcPct val="125000"/>
+              </a:lnSpc>
               <a:spcBef>
-                <a:spcPts val="1600"/>
+                <a:spcPts val="0"/>
               </a:spcBef>
+              <a:spcAft>
+                <a:spcPts val="800"/>
+              </a:spcAft>
               <a:defRPr sz="2200" b="0">
                 <a:solidFill>
                   <a:srgbClr val="E3C76F"/>
@@ -3209,7 +3417,13 @@
               </a:defRPr>
             </a:pPr>
             <a:r>
-              <a:t>Aura Energy — Premium Functional Beverages (East Africa)</a:t>
+              <a:rPr sz="1600">
+                <a:solidFill>
+                  <a:srgbClr val="CDD6F4"/>
+                </a:solidFill>
+                <a:latin typeface="JetBrains Mono"/>
+              </a:rPr>
+              <a:t>• Aura Energy — Premium Functional Beverages (East Africa)</a:t>
             </a:r>
           </a:p>
         </p:txBody>
@@ -3222,8 +3436,8 @@
         </p:nvSpPr>
         <p:spPr>
           <a:xfrm>
-            <a:off x="685800" y="4754880"/>
-            <a:ext cx="10515600" cy="1828800"/>
+            <a:off x="1341086" y="4754880"/>
+            <a:ext cx="9753356" cy="1828800"/>
           </a:xfrm>
           <a:prstGeom prst="rect">
             <a:avLst/>
@@ -3231,68 +3445,150 @@
           <a:noFill/>
         </p:spPr>
         <p:txBody>
+          <a:bodyPr wrap="square">
+            <a:spAutoFit/>
+          </a:bodyPr>
+          <a:lstStyle/>
+          <a:p>
+            <a:pPr>
+              <a:lnSpc>
+                <a:spcPct val="125000"/>
+              </a:lnSpc>
+              <a:spcBef>
+                <a:spcPts val="0"/>
+              </a:spcBef>
+              <a:spcAft>
+                <a:spcPts val="800"/>
+              </a:spcAft>
+              <a:defRPr sz="1500" b="1">
+                <a:solidFill>
+                  <a:srgbClr val="282D37"/>
+                </a:solidFill>
+              </a:defRPr>
+            </a:pPr>
+            <a:r>
+              <a:rPr b="1" sz="3800">
+                <a:solidFill>
+                  <a:srgbClr val="EEF2FF"/>
+                </a:solidFill>
+                <a:latin typeface="JetBrains Mono"/>
+              </a:rPr>
+              <a:t>John Alexander Kamau</a:t>
+            </a:r>
+          </a:p>
+          <a:p>
+            <a:pPr>
+              <a:lnSpc>
+                <a:spcPct val="125000"/>
+              </a:lnSpc>
+              <a:spcBef>
+                <a:spcPts val="0"/>
+              </a:spcBef>
+              <a:spcAft>
+                <a:spcPts val="800"/>
+              </a:spcAft>
+              <a:defRPr sz="1500" b="1">
+                <a:solidFill>
+                  <a:srgbClr val="282D37"/>
+                </a:solidFill>
+              </a:defRPr>
+            </a:pPr>
+            <a:r>
+              <a:rPr sz="1600">
+                <a:solidFill>
+                  <a:srgbClr val="CDD6F4"/>
+                </a:solidFill>
+                <a:latin typeface="JetBrains Mono"/>
+              </a:rPr>
+              <a:t>• Student No. 20-0471</a:t>
+            </a:r>
+          </a:p>
+          <a:p>
+            <a:pPr>
+              <a:lnSpc>
+                <a:spcPct val="125000"/>
+              </a:lnSpc>
+              <a:spcBef>
+                <a:spcPts val="0"/>
+              </a:spcBef>
+              <a:spcAft>
+                <a:spcPts val="800"/>
+              </a:spcAft>
+              <a:defRPr sz="1500" b="0">
+                <a:solidFill>
+                  <a:srgbClr val="4B5563"/>
+                </a:solidFill>
+              </a:defRPr>
+            </a:pPr>
+            <a:r>
+              <a:rPr sz="1600">
+                <a:solidFill>
+                  <a:srgbClr val="CDD6F4"/>
+                </a:solidFill>
+                <a:latin typeface="JetBrains Mono"/>
+              </a:rPr>
+              <a:t>• School of Communication  ·  January–April 2026</a:t>
+            </a:r>
+          </a:p>
+          <a:p>
+            <a:pPr>
+              <a:lnSpc>
+                <a:spcPct val="125000"/>
+              </a:lnSpc>
+              <a:spcBef>
+                <a:spcPts val="0"/>
+              </a:spcBef>
+              <a:spcAft>
+                <a:spcPts val="800"/>
+              </a:spcAft>
+              <a:defRPr sz="1500" b="0">
+                <a:solidFill>
+                  <a:srgbClr val="4B5563"/>
+                </a:solidFill>
+              </a:defRPr>
+            </a:pPr>
+            <a:r>
+              <a:rPr sz="1600">
+                <a:solidFill>
+                  <a:srgbClr val="CDD6F4"/>
+                </a:solidFill>
+                <a:latin typeface="JetBrains Mono"/>
+              </a:rPr>
+              <a:t>• Submission date: 1 April 2026 (per course outline)</a:t>
+            </a:r>
+          </a:p>
+        </p:txBody>
+      </p:sp>
+      <p:sp>
+        <p:nvSpPr>
+          <p:cNvPr id="9" name="TextBox 8"/>
+          <p:cNvSpPr txBox="1"/>
+          <p:nvPr/>
+        </p:nvSpPr>
+        <p:spPr>
+          <a:xfrm>
+            <a:off x="1097252" y="6309360"/>
+            <a:ext cx="9997189" cy="342900"/>
+          </a:xfrm>
+          <a:prstGeom prst="rect">
+            <a:avLst/>
+          </a:prstGeom>
+          <a:noFill/>
+        </p:spPr>
+        <p:txBody>
           <a:bodyPr wrap="none">
             <a:spAutoFit/>
           </a:bodyPr>
           <a:lstStyle/>
           <a:p>
-            <a:pPr>
-              <a:spcAft>
-                <a:spcPts val="600"/>
-              </a:spcAft>
-              <a:defRPr sz="1500" b="1">
-                <a:solidFill>
-                  <a:srgbClr val="282D37"/>
-                </a:solidFill>
-              </a:defRPr>
-            </a:pPr>
-            <a:r>
-              <a:t>John Alexander Kamau</a:t>
-            </a:r>
-          </a:p>
-          <a:p>
-            <a:pPr>
-              <a:spcAft>
-                <a:spcPts val="600"/>
-              </a:spcAft>
-              <a:defRPr sz="1500" b="1">
-                <a:solidFill>
-                  <a:srgbClr val="282D37"/>
-                </a:solidFill>
-              </a:defRPr>
-            </a:pPr>
-            <a:r>
-              <a:t>Student No. 20-0471</a:t>
-            </a:r>
-          </a:p>
-          <a:p>
-            <a:pPr>
-              <a:spcAft>
-                <a:spcPts val="600"/>
-              </a:spcAft>
-              <a:defRPr sz="1500" b="0">
-                <a:solidFill>
-                  <a:srgbClr val="4B5563"/>
-                </a:solidFill>
-              </a:defRPr>
-            </a:pPr>
-            <a:r>
-              <a:t>School of Communication  ·  January–April 2026</a:t>
-            </a:r>
-          </a:p>
-          <a:p>
-            <a:pPr>
-              <a:spcAft>
-                <a:spcPts val="600"/>
-              </a:spcAft>
-              <a:defRPr sz="1500" b="0">
-                <a:solidFill>
-                  <a:srgbClr val="4B5563"/>
-                </a:solidFill>
-              </a:defRPr>
-            </a:pPr>
-            <a:r>
-              <a:t>Submission date: 1 April 2026 (per course outline)</a:t>
+            <a:r>
+              <a:rPr sz="1000">
+                <a:solidFill>
+                  <a:srgbClr val="7F849C"/>
+                </a:solidFill>
+                <a:latin typeface="JetBrains Mono"/>
+              </a:rPr>
+              <a:t>AURA ENERGY  |  PRC 305 WEB DEVELOPMENT PROJECT</a:t>
             </a:r>
           </a:p>
         </p:txBody>
@@ -3317,201 +3613,25 @@
       <p:grpSpPr/>
       <p:sp>
         <p:nvSpPr>
-          <p:cNvPr id="2" name="Title 1"/>
-          <p:cNvSpPr>
-            <a:spLocks noGrp="1"/>
-          </p:cNvSpPr>
-          <p:nvPr>
-            <p:ph type="title"/>
-          </p:nvPr>
-        </p:nvSpPr>
-        <p:spPr/>
-        <p:txBody>
-          <a:bodyPr/>
-          <a:lstStyle/>
-          <a:p>
-            <a:pPr>
-              <a:defRPr sz="2800" b="1">
-                <a:solidFill>
-                  <a:srgbClr val="060D18"/>
-                </a:solidFill>
-              </a:defRPr>
-            </a:pPr>
-            <a:r>
-              <a:t>Technology Stack</a:t>
-            </a:r>
-          </a:p>
-        </p:txBody>
-      </p:sp>
-      <p:sp>
-        <p:nvSpPr>
-          <p:cNvPr id="3" name="Content Placeholder 2"/>
-          <p:cNvSpPr>
-            <a:spLocks noGrp="1"/>
-          </p:cNvSpPr>
-          <p:nvPr>
-            <p:ph idx="1"/>
-          </p:nvPr>
-        </p:nvSpPr>
-        <p:spPr/>
-        <p:txBody>
-          <a:bodyPr/>
-          <a:lstStyle/>
-          <a:p>
-            <a:pPr>
-              <a:spcAft>
-                <a:spcPts val="800"/>
-              </a:spcAft>
-              <a:defRPr sz="1700">
-                <a:solidFill>
-                  <a:srgbClr val="4B5563"/>
-                </a:solidFill>
-              </a:defRPr>
-            </a:pPr>
-            <a:r>
-              <a:t>WordPress + Elementor for fast, structured content building.</a:t>
-            </a:r>
-          </a:p>
-          <a:p>
-            <a:pPr/>
-            <a:r>
-              <a:t>Hello Elementor theme for lightweight performance.</a:t>
-            </a:r>
-          </a:p>
-          <a:p>
-            <a:pPr/>
-            <a:r>
-              <a:t>MetForm plugin for contact form functionality.</a:t>
-            </a:r>
-          </a:p>
-        </p:txBody>
-      </p:sp>
-    </p:spTree>
-  </p:cSld>
-  <p:clrMapOvr>
-    <a:masterClrMapping/>
-  </p:clrMapOvr>
-</p:sld>
-</file>
-
-<file path=ppt/slides/slide11.xml><?xml version="1.0" encoding="utf-8"?>
-<p:sld xmlns:a="http://schemas.openxmlformats.org/drawingml/2006/main" xmlns:p="http://schemas.openxmlformats.org/presentationml/2006/main" xmlns:r="http://schemas.openxmlformats.org/officeDocument/2006/relationships">
-  <p:cSld>
-    <p:spTree>
-      <p:nvGrpSpPr>
-        <p:cNvPr id="1" name=""/>
-        <p:cNvGrpSpPr/>
-        <p:nvPr/>
-      </p:nvGrpSpPr>
-      <p:grpSpPr/>
-      <p:sp>
-        <p:nvSpPr>
-          <p:cNvPr id="2" name="Title 1"/>
-          <p:cNvSpPr>
-            <a:spLocks noGrp="1"/>
-          </p:cNvSpPr>
-          <p:nvPr>
-            <p:ph type="title"/>
-          </p:nvPr>
-        </p:nvSpPr>
-        <p:spPr/>
-        <p:txBody>
-          <a:bodyPr/>
-          <a:lstStyle/>
-          <a:p>
-            <a:pPr>
-              <a:defRPr sz="2800" b="1">
-                <a:solidFill>
-                  <a:srgbClr val="060D18"/>
-                </a:solidFill>
-              </a:defRPr>
-            </a:pPr>
-            <a:r>
-              <a:t>Development Approach</a:t>
-            </a:r>
-          </a:p>
-        </p:txBody>
-      </p:sp>
-      <p:sp>
-        <p:nvSpPr>
-          <p:cNvPr id="3" name="Content Placeholder 2"/>
-          <p:cNvSpPr>
-            <a:spLocks noGrp="1"/>
-          </p:cNvSpPr>
-          <p:nvPr>
-            <p:ph idx="1"/>
-          </p:nvPr>
-        </p:nvSpPr>
-        <p:spPr/>
-        <p:txBody>
-          <a:bodyPr/>
-          <a:lstStyle/>
-          <a:p>
-            <a:pPr>
-              <a:spcAft>
-                <a:spcPts val="800"/>
-              </a:spcAft>
-              <a:defRPr sz="1700">
-                <a:solidFill>
-                  <a:srgbClr val="4B5563"/>
-                </a:solidFill>
-              </a:defRPr>
-            </a:pPr>
-            <a:r>
-              <a:t>Planned pages and content before build.</a:t>
-            </a:r>
-          </a:p>
-          <a:p>
-            <a:pPr/>
-            <a:r>
-              <a:t>Implemented consistent styles across all pages.</a:t>
-            </a:r>
-          </a:p>
-          <a:p>
-            <a:pPr/>
-            <a:r>
-              <a:t>Used repeatable setup steps to keep content and layout aligned.</a:t>
-            </a:r>
-          </a:p>
-        </p:txBody>
-      </p:sp>
-    </p:spTree>
-  </p:cSld>
-  <p:clrMapOvr>
-    <a:masterClrMapping/>
-  </p:clrMapOvr>
-</p:sld>
-</file>
-
-<file path=ppt/slides/slide12.xml><?xml version="1.0" encoding="utf-8"?>
-<p:sld xmlns:a="http://schemas.openxmlformats.org/drawingml/2006/main" xmlns:p="http://schemas.openxmlformats.org/presentationml/2006/main" xmlns:r="http://schemas.openxmlformats.org/officeDocument/2006/relationships">
-  <p:cSld>
-    <p:spTree>
-      <p:nvGrpSpPr>
-        <p:cNvPr id="1" name=""/>
-        <p:cNvGrpSpPr/>
-        <p:nvPr/>
-      </p:nvGrpSpPr>
-      <p:grpSpPr/>
-      <p:sp>
-        <p:nvSpPr>
-          <p:cNvPr id="2" name="Rectangle 1"/>
+          <p:cNvPr id="7" name="Rounded Rectangle 6"/>
           <p:cNvSpPr/>
           <p:nvPr/>
         </p:nvSpPr>
         <p:spPr>
           <a:xfrm>
-            <a:off x="0" y="0"/>
-            <a:ext cx="12191695" cy="6858000"/>
-          </a:xfrm>
-          <a:prstGeom prst="rect">
+            <a:off x="975335" y="822960"/>
+            <a:ext cx="10484857" cy="5349240"/>
+          </a:xfrm>
+          <a:prstGeom prst="roundRect">
             <a:avLst/>
           </a:prstGeom>
           <a:solidFill>
-            <a:srgbClr val="060D18"/>
+            <a:srgbClr val="313244"/>
           </a:solidFill>
-          <a:ln>
-            <a:noFill/>
+          <a:ln w="15240">
+            <a:solidFill>
+              <a:srgbClr val="45475A"/>
+            </a:solidFill>
           </a:ln>
         </p:spPr>
         <p:style>
@@ -3538,272 +3658,20 @@
       </p:sp>
       <p:sp>
         <p:nvSpPr>
-          <p:cNvPr id="3" name="TextBox 2"/>
-          <p:cNvSpPr txBox="1"/>
-          <p:nvPr/>
-        </p:nvSpPr>
-        <p:spPr>
-          <a:xfrm>
-            <a:off x="685800" y="2560320"/>
-            <a:ext cx="10515600" cy="1828800"/>
-          </a:xfrm>
-          <a:prstGeom prst="rect">
-            <a:avLst/>
-          </a:prstGeom>
-          <a:noFill/>
-        </p:spPr>
-        <p:txBody>
-          <a:bodyPr wrap="none">
-            <a:spAutoFit/>
-          </a:bodyPr>
-          <a:lstStyle/>
-          <a:p>
-            <a:pPr>
-              <a:defRPr sz="3600" b="1">
-                <a:solidFill>
-                  <a:srgbClr val="E3C76F"/>
-                </a:solidFill>
-              </a:defRPr>
-            </a:pPr>
-            <a:r>
-              <a:t>Demonstration</a:t>
-            </a:r>
-          </a:p>
-          <a:p>
-            <a:pPr>
-              <a:spcBef>
-                <a:spcPts val="1400"/>
-              </a:spcBef>
-              <a:defRPr sz="1800">
-                <a:solidFill>
-                  <a:srgbClr val="C8D2DC"/>
-                </a:solidFill>
-              </a:defRPr>
-            </a:pPr>
-            <a:r>
-              <a:t>Live site</a:t>
-            </a:r>
-          </a:p>
-        </p:txBody>
-      </p:sp>
-    </p:spTree>
-  </p:cSld>
-  <p:clrMapOvr>
-    <a:masterClrMapping/>
-  </p:clrMapOvr>
-</p:sld>
-</file>
-
-<file path=ppt/slides/slide13.xml><?xml version="1.0" encoding="utf-8"?>
-<p:sld xmlns:a="http://schemas.openxmlformats.org/drawingml/2006/main" xmlns:p="http://schemas.openxmlformats.org/presentationml/2006/main" xmlns:r="http://schemas.openxmlformats.org/officeDocument/2006/relationships">
-  <p:cSld>
-    <p:spTree>
-      <p:nvGrpSpPr>
-        <p:cNvPr id="1" name=""/>
-        <p:cNvGrpSpPr/>
-        <p:nvPr/>
-      </p:nvGrpSpPr>
-      <p:grpSpPr/>
-      <p:sp>
-        <p:nvSpPr>
-          <p:cNvPr id="2" name="Title 1"/>
-          <p:cNvSpPr>
-            <a:spLocks noGrp="1"/>
-          </p:cNvSpPr>
-          <p:nvPr>
-            <p:ph type="title"/>
-          </p:nvPr>
-        </p:nvSpPr>
-        <p:spPr/>
-        <p:txBody>
-          <a:bodyPr/>
-          <a:lstStyle/>
-          <a:p>
-            <a:pPr>
-              <a:defRPr sz="2800" b="1">
-                <a:solidFill>
-                  <a:srgbClr val="060D18"/>
-                </a:solidFill>
-              </a:defRPr>
-            </a:pPr>
-            <a:r>
-              <a:t>Live Demonstration</a:t>
-            </a:r>
-          </a:p>
-        </p:txBody>
-      </p:sp>
-      <p:sp>
-        <p:nvSpPr>
-          <p:cNvPr id="3" name="Content Placeholder 2"/>
-          <p:cNvSpPr>
-            <a:spLocks noGrp="1"/>
-          </p:cNvSpPr>
-          <p:nvPr>
-            <p:ph idx="1"/>
-          </p:nvPr>
-        </p:nvSpPr>
-        <p:spPr/>
-        <p:txBody>
-          <a:bodyPr/>
-          <a:lstStyle/>
-          <a:p>
-            <a:pPr>
-              <a:spcAft>
-                <a:spcPts val="800"/>
-              </a:spcAft>
-              <a:defRPr sz="1700">
-                <a:solidFill>
-                  <a:srgbClr val="4B5563"/>
-                </a:solidFill>
-              </a:defRPr>
-            </a:pPr>
-            <a:r>
-              <a:t>Show Home, About, Products, and Contact pages.</a:t>
-            </a:r>
-          </a:p>
-          <a:p>
-            <a:pPr/>
-            <a:r>
-              <a:t>Demonstrate responsive behavior (desktop and mobile view).</a:t>
-            </a:r>
-          </a:p>
-          <a:p>
-            <a:pPr/>
-            <a:r>
-              <a:t>Submit contact form to show validation and success response.</a:t>
-            </a:r>
-          </a:p>
-        </p:txBody>
-      </p:sp>
-    </p:spTree>
-  </p:cSld>
-  <p:clrMapOvr>
-    <a:masterClrMapping/>
-  </p:clrMapOvr>
-</p:sld>
-</file>
-
-<file path=ppt/slides/slide14.xml><?xml version="1.0" encoding="utf-8"?>
-<p:sld xmlns:a="http://schemas.openxmlformats.org/drawingml/2006/main" xmlns:p="http://schemas.openxmlformats.org/presentationml/2006/main" xmlns:r="http://schemas.openxmlformats.org/officeDocument/2006/relationships">
-  <p:cSld>
-    <p:spTree>
-      <p:nvGrpSpPr>
-        <p:cNvPr id="1" name=""/>
-        <p:cNvGrpSpPr/>
-        <p:nvPr/>
-      </p:nvGrpSpPr>
-      <p:grpSpPr/>
-      <p:sp>
-        <p:nvSpPr>
-          <p:cNvPr id="2" name="Title 1"/>
-          <p:cNvSpPr>
-            <a:spLocks noGrp="1"/>
-          </p:cNvSpPr>
-          <p:nvPr>
-            <p:ph type="title"/>
-          </p:nvPr>
-        </p:nvSpPr>
-        <p:spPr/>
-        <p:txBody>
-          <a:bodyPr/>
-          <a:lstStyle/>
-          <a:p>
-            <a:pPr>
-              <a:defRPr sz="2800" b="1">
-                <a:solidFill>
-                  <a:srgbClr val="060D18"/>
-                </a:solidFill>
-              </a:defRPr>
-            </a:pPr>
-            <a:r>
-              <a:t>Submission Materials</a:t>
-            </a:r>
-          </a:p>
-        </p:txBody>
-      </p:sp>
-      <p:sp>
-        <p:nvSpPr>
-          <p:cNvPr id="3" name="Content Placeholder 2"/>
-          <p:cNvSpPr>
-            <a:spLocks noGrp="1"/>
-          </p:cNvSpPr>
-          <p:nvPr>
-            <p:ph idx="1"/>
-          </p:nvPr>
-        </p:nvSpPr>
-        <p:spPr/>
-        <p:txBody>
-          <a:bodyPr/>
-          <a:lstStyle/>
-          <a:p>
-            <a:pPr>
-              <a:spcAft>
-                <a:spcPts val="800"/>
-              </a:spcAft>
-              <a:defRPr sz="1700">
-                <a:solidFill>
-                  <a:srgbClr val="4B5563"/>
-                </a:solidFill>
-              </a:defRPr>
-            </a:pPr>
-            <a:r>
-              <a:t>Live website URL</a:t>
-            </a:r>
-          </a:p>
-          <a:p>
-            <a:pPr/>
-            <a:r>
-              <a:t>Source repository link</a:t>
-            </a:r>
-          </a:p>
-          <a:p>
-            <a:pPr/>
-            <a:r>
-              <a:t>Final presentation slides</a:t>
-            </a:r>
-          </a:p>
-          <a:p>
-            <a:pPr/>
-            <a:r>
-              <a:t>Any required supporting documentation</a:t>
-            </a:r>
-          </a:p>
-        </p:txBody>
-      </p:sp>
-    </p:spTree>
-  </p:cSld>
-  <p:clrMapOvr>
-    <a:masterClrMapping/>
-  </p:clrMapOvr>
-</p:sld>
-</file>
-
-<file path=ppt/slides/slide15.xml><?xml version="1.0" encoding="utf-8"?>
-<p:sld xmlns:a="http://schemas.openxmlformats.org/drawingml/2006/main" xmlns:p="http://schemas.openxmlformats.org/presentationml/2006/main" xmlns:r="http://schemas.openxmlformats.org/officeDocument/2006/relationships">
-  <p:cSld>
-    <p:spTree>
-      <p:nvGrpSpPr>
-        <p:cNvPr id="1" name=""/>
-        <p:cNvGrpSpPr/>
-        <p:nvPr/>
-      </p:nvGrpSpPr>
-      <p:grpSpPr/>
-      <p:sp>
-        <p:nvSpPr>
-          <p:cNvPr id="2" name="Rectangle 1"/>
+          <p:cNvPr id="6" name="Rectangle 5"/>
           <p:cNvSpPr/>
           <p:nvPr/>
         </p:nvSpPr>
         <p:spPr>
           <a:xfrm>
-            <a:off x="0" y="0"/>
-            <a:ext cx="12191695" cy="6858000"/>
+            <a:off x="487667" y="548640"/>
+            <a:ext cx="73150" cy="5760720"/>
           </a:xfrm>
           <a:prstGeom prst="rect">
             <a:avLst/>
           </a:prstGeom>
           <a:solidFill>
-            <a:srgbClr val="060D18"/>
+            <a:srgbClr val="CBA6F7"/>
           </a:solidFill>
           <a:ln>
             <a:noFill/>
@@ -3833,14 +3701,304 @@
       </p:sp>
       <p:sp>
         <p:nvSpPr>
-          <p:cNvPr id="3" name="TextBox 2"/>
+          <p:cNvPr id="5" name="Rectangle 4"/>
+          <p:cNvSpPr/>
+          <p:nvPr/>
+        </p:nvSpPr>
+        <p:spPr>
+          <a:xfrm>
+            <a:off x="0" y="0"/>
+            <a:ext cx="12191695" cy="1234440"/>
+          </a:xfrm>
+          <a:prstGeom prst="rect">
+            <a:avLst/>
+          </a:prstGeom>
+          <a:solidFill>
+            <a:srgbClr val="162343"/>
+          </a:solidFill>
+          <a:ln>
+            <a:noFill/>
+          </a:ln>
+        </p:spPr>
+        <p:style>
+          <a:lnRef idx="1">
+            <a:schemeClr val="accent1"/>
+          </a:lnRef>
+          <a:fillRef idx="3">
+            <a:schemeClr val="accent1"/>
+          </a:fillRef>
+          <a:effectRef idx="2">
+            <a:schemeClr val="accent1"/>
+          </a:effectRef>
+          <a:fontRef idx="minor">
+            <a:schemeClr val="lt1"/>
+          </a:fontRef>
+        </p:style>
+        <p:txBody>
+          <a:bodyPr rtlCol="0" anchor="ctr"/>
+          <a:lstStyle/>
+          <a:p>
+            <a:pPr algn="ctr"/>
+          </a:p>
+        </p:txBody>
+      </p:sp>
+      <p:sp>
+        <p:nvSpPr>
+          <p:cNvPr id="4" name="Rectangle 3"/>
+          <p:cNvSpPr/>
+          <p:nvPr/>
+        </p:nvSpPr>
+        <p:spPr>
+          <a:xfrm>
+            <a:off x="0" y="0"/>
+            <a:ext cx="12191695" cy="6858000"/>
+          </a:xfrm>
+          <a:prstGeom prst="rect">
+            <a:avLst/>
+          </a:prstGeom>
+          <a:solidFill>
+            <a:srgbClr val="1E1E2E"/>
+          </a:solidFill>
+          <a:ln>
+            <a:noFill/>
+          </a:ln>
+        </p:spPr>
+        <p:style>
+          <a:lnRef idx="1">
+            <a:schemeClr val="accent1"/>
+          </a:lnRef>
+          <a:fillRef idx="3">
+            <a:schemeClr val="accent1"/>
+          </a:fillRef>
+          <a:effectRef idx="2">
+            <a:schemeClr val="accent1"/>
+          </a:effectRef>
+          <a:fontRef idx="minor">
+            <a:schemeClr val="lt1"/>
+          </a:fontRef>
+        </p:style>
+        <p:txBody>
+          <a:bodyPr rtlCol="0" anchor="ctr"/>
+          <a:lstStyle/>
+          <a:p>
+            <a:pPr algn="ctr"/>
+          </a:p>
+        </p:txBody>
+      </p:sp>
+      <p:sp>
+        <p:nvSpPr>
+          <p:cNvPr id="2" name="Title 1"/>
+          <p:cNvSpPr>
+            <a:spLocks noGrp="1"/>
+          </p:cNvSpPr>
+          <p:nvPr>
+            <p:ph type="title"/>
+          </p:nvPr>
+        </p:nvSpPr>
+        <p:spPr>
+          <a:xfrm>
+            <a:off x="1341086" y="1028700"/>
+          </a:xfrm>
+        </p:spPr>
+        <p:txBody>
+          <a:bodyPr wrap="square"/>
+          <a:lstStyle/>
+          <a:p>
+            <a:pPr>
+              <a:lnSpc>
+                <a:spcPct val="125000"/>
+              </a:lnSpc>
+              <a:spcBef>
+                <a:spcPts val="0"/>
+              </a:spcBef>
+              <a:spcAft>
+                <a:spcPts val="800"/>
+              </a:spcAft>
+              <a:defRPr sz="2800" b="1">
+                <a:solidFill>
+                  <a:srgbClr val="060D18"/>
+                </a:solidFill>
+              </a:defRPr>
+            </a:pPr>
+            <a:r>
+              <a:rPr b="1" sz="3000">
+                <a:solidFill>
+                  <a:srgbClr val="EEF2FF"/>
+                </a:solidFill>
+                <a:latin typeface="JetBrains Mono"/>
+              </a:rPr>
+              <a:t>Recommendations, Conclusion &amp; Q&amp;A</a:t>
+            </a:r>
+          </a:p>
+        </p:txBody>
+      </p:sp>
+      <p:sp>
+        <p:nvSpPr>
+          <p:cNvPr id="3" name="Content Placeholder 2"/>
+          <p:cNvSpPr>
+            <a:spLocks noGrp="1"/>
+          </p:cNvSpPr>
+          <p:nvPr>
+            <p:ph idx="1"/>
+          </p:nvPr>
+        </p:nvSpPr>
+        <p:spPr>
+          <a:xfrm>
+            <a:off x="1341086" y="0"/>
+          </a:xfrm>
+        </p:spPr>
+        <p:txBody>
+          <a:bodyPr wrap="square"/>
+          <a:lstStyle/>
+          <a:p>
+            <a:pPr>
+              <a:lnSpc>
+                <a:spcPct val="125000"/>
+              </a:lnSpc>
+              <a:spcBef>
+                <a:spcPts val="0"/>
+              </a:spcBef>
+              <a:spcAft>
+                <a:spcPts val="800"/>
+              </a:spcAft>
+              <a:defRPr sz="1700">
+                <a:solidFill>
+                  <a:srgbClr val="4B5563"/>
+                </a:solidFill>
+              </a:defRPr>
+            </a:pPr>
+            <a:r>
+              <a:rPr sz="1700">
+                <a:solidFill>
+                  <a:srgbClr val="CDD6F4"/>
+                </a:solidFill>
+                <a:latin typeface="JetBrains Mono"/>
+              </a:rPr>
+              <a:t>Recommendations: continue improving content, SEO metadata, and social rollout.</a:t>
+            </a:r>
+          </a:p>
+          <a:p>
+            <a:pPr>
+              <a:lnSpc>
+                <a:spcPct val="125000"/>
+              </a:lnSpc>
+              <a:spcBef>
+                <a:spcPts val="0"/>
+              </a:spcBef>
+              <a:spcAft>
+                <a:spcPts val="800"/>
+              </a:spcAft>
+            </a:pPr>
+            <a:r>
+              <a:rPr sz="1600">
+                <a:solidFill>
+                  <a:srgbClr val="CDD6F4"/>
+                </a:solidFill>
+                <a:latin typeface="JetBrains Mono"/>
+              </a:rPr>
+              <a:t>• Conclusion: project meets PRC305 functional, design, structure, and presentation outcomes.</a:t>
+            </a:r>
+          </a:p>
+          <a:p>
+            <a:pPr>
+              <a:lnSpc>
+                <a:spcPct val="125000"/>
+              </a:lnSpc>
+              <a:spcBef>
+                <a:spcPts val="0"/>
+              </a:spcBef>
+              <a:spcAft>
+                <a:spcPts val="800"/>
+              </a:spcAft>
+            </a:pPr>
+            <a:r>
+              <a:rPr sz="1600">
+                <a:solidFill>
+                  <a:srgbClr val="CDD6F4"/>
+                </a:solidFill>
+                <a:latin typeface="JetBrains Mono"/>
+              </a:rPr>
+              <a:t>• Submission evidence: Live URL - https://08e8-41-90-185-182.ngrok-free.app/wordpress</a:t>
+            </a:r>
+          </a:p>
+          <a:p>
+            <a:pPr>
+              <a:lnSpc>
+                <a:spcPct val="125000"/>
+              </a:lnSpc>
+              <a:spcBef>
+                <a:spcPts val="0"/>
+              </a:spcBef>
+              <a:spcAft>
+                <a:spcPts val="800"/>
+              </a:spcAft>
+            </a:pPr>
+            <a:r>
+              <a:rPr sz="1600">
+                <a:solidFill>
+                  <a:srgbClr val="CDD6F4"/>
+                </a:solidFill>
+                <a:latin typeface="JetBrains Mono"/>
+              </a:rPr>
+              <a:t>• GitHub Repository - https://github.com/Xander-AJ/PRC-305x---Aura-Website</a:t>
+            </a:r>
+          </a:p>
+          <a:p>
+            <a:pPr>
+              <a:lnSpc>
+                <a:spcPct val="125000"/>
+              </a:lnSpc>
+              <a:spcBef>
+                <a:spcPts val="0"/>
+              </a:spcBef>
+              <a:spcAft>
+                <a:spcPts val="800"/>
+              </a:spcAft>
+            </a:pPr>
+            <a:r>
+              <a:rPr sz="1600">
+                <a:solidFill>
+                  <a:srgbClr val="CDD6F4"/>
+                </a:solidFill>
+                <a:latin typeface="JetBrains Mono"/>
+              </a:rPr>
+              <a:t>• Local backup URL - http://localhost/wordpress/</a:t>
+            </a:r>
+          </a:p>
+          <a:p>
+            <a:pPr>
+              <a:lnSpc>
+                <a:spcPct val="125000"/>
+              </a:lnSpc>
+              <a:spcBef>
+                <a:spcPts val="0"/>
+              </a:spcBef>
+              <a:spcAft>
+                <a:spcPts val="800"/>
+              </a:spcAft>
+            </a:pPr>
+            <a:r>
+              <a:rPr sz="1600">
+                <a:solidFill>
+                  <a:srgbClr val="CDD6F4"/>
+                </a:solidFill>
+                <a:latin typeface="JetBrains Mono"/>
+              </a:rPr>
+              <a:t>• Thank you - Questions and feedback welcome.</a:t>
+            </a:r>
+          </a:p>
+        </p:txBody>
+      </p:sp>
+      <p:sp>
+        <p:nvSpPr>
+          <p:cNvPr id="8" name="TextBox 7"/>
           <p:cNvSpPr txBox="1"/>
           <p:nvPr/>
         </p:nvSpPr>
         <p:spPr>
           <a:xfrm>
-            <a:off x="685800" y="2560320"/>
-            <a:ext cx="10515600" cy="1828800"/>
+            <a:off x="1097252" y="6309360"/>
+            <a:ext cx="9997189" cy="342900"/>
           </a:xfrm>
           <a:prstGeom prst="rect">
             <a:avLst/>
@@ -3853,404 +4011,14 @@
           </a:bodyPr>
           <a:lstStyle/>
           <a:p>
-            <a:pPr>
-              <a:defRPr sz="3600" b="1">
-                <a:solidFill>
-                  <a:srgbClr val="E3C76F"/>
-                </a:solidFill>
-              </a:defRPr>
-            </a:pPr>
-            <a:r>
-              <a:t>Reflection</a:t>
-            </a:r>
-          </a:p>
-          <a:p>
-            <a:pPr>
-              <a:spcBef>
-                <a:spcPts val="1400"/>
-              </a:spcBef>
-              <a:defRPr sz="1800">
-                <a:solidFill>
-                  <a:srgbClr val="C8D2DC"/>
-                </a:solidFill>
-              </a:defRPr>
-            </a:pPr>
-            <a:r>
-              <a:t>Challenges &amp; outcomes</a:t>
-            </a:r>
-          </a:p>
-        </p:txBody>
-      </p:sp>
-    </p:spTree>
-  </p:cSld>
-  <p:clrMapOvr>
-    <a:masterClrMapping/>
-  </p:clrMapOvr>
-</p:sld>
-</file>
-
-<file path=ppt/slides/slide16.xml><?xml version="1.0" encoding="utf-8"?>
-<p:sld xmlns:a="http://schemas.openxmlformats.org/drawingml/2006/main" xmlns:p="http://schemas.openxmlformats.org/presentationml/2006/main" xmlns:r="http://schemas.openxmlformats.org/officeDocument/2006/relationships">
-  <p:cSld>
-    <p:spTree>
-      <p:nvGrpSpPr>
-        <p:cNvPr id="1" name=""/>
-        <p:cNvGrpSpPr/>
-        <p:nvPr/>
-      </p:nvGrpSpPr>
-      <p:grpSpPr/>
-      <p:sp>
-        <p:nvSpPr>
-          <p:cNvPr id="2" name="Title 1"/>
-          <p:cNvSpPr>
-            <a:spLocks noGrp="1"/>
-          </p:cNvSpPr>
-          <p:nvPr>
-            <p:ph type="title"/>
-          </p:nvPr>
-        </p:nvSpPr>
-        <p:spPr/>
-        <p:txBody>
-          <a:bodyPr/>
-          <a:lstStyle/>
-          <a:p>
-            <a:pPr>
-              <a:defRPr sz="2800" b="1">
-                <a:solidFill>
-                  <a:srgbClr val="060D18"/>
-                </a:solidFill>
-              </a:defRPr>
-            </a:pPr>
-            <a:r>
-              <a:t>Challenges &amp; Solutions</a:t>
-            </a:r>
-          </a:p>
-        </p:txBody>
-      </p:sp>
-      <p:sp>
-        <p:nvSpPr>
-          <p:cNvPr id="3" name="Content Placeholder 2"/>
-          <p:cNvSpPr>
-            <a:spLocks noGrp="1"/>
-          </p:cNvSpPr>
-          <p:nvPr>
-            <p:ph idx="1"/>
-          </p:nvPr>
-        </p:nvSpPr>
-        <p:spPr/>
-        <p:txBody>
-          <a:bodyPr/>
-          <a:lstStyle/>
-          <a:p>
-            <a:pPr>
-              <a:spcAft>
-                <a:spcPts val="800"/>
-              </a:spcAft>
-              <a:defRPr sz="1700">
-                <a:solidFill>
-                  <a:srgbClr val="4B5563"/>
-                </a:solidFill>
-              </a:defRPr>
-            </a:pPr>
-            <a:r>
-              <a:t>Keeping content and layout consistent across pages.</a:t>
-            </a:r>
-          </a:p>
-          <a:p>
-            <a:pPr/>
-            <a:r>
-              <a:t>Ensuring form reliability and clear validation messages.</a:t>
-            </a:r>
-          </a:p>
-          <a:p>
-            <a:pPr/>
-            <a:r>
-              <a:t>Balancing visual quality with simple navigation and performance.</a:t>
-            </a:r>
-          </a:p>
-        </p:txBody>
-      </p:sp>
-    </p:spTree>
-  </p:cSld>
-  <p:clrMapOvr>
-    <a:masterClrMapping/>
-  </p:clrMapOvr>
-</p:sld>
-</file>
-
-<file path=ppt/slides/slide17.xml><?xml version="1.0" encoding="utf-8"?>
-<p:sld xmlns:a="http://schemas.openxmlformats.org/drawingml/2006/main" xmlns:p="http://schemas.openxmlformats.org/presentationml/2006/main" xmlns:r="http://schemas.openxmlformats.org/officeDocument/2006/relationships">
-  <p:cSld>
-    <p:spTree>
-      <p:nvGrpSpPr>
-        <p:cNvPr id="1" name=""/>
-        <p:cNvGrpSpPr/>
-        <p:nvPr/>
-      </p:nvGrpSpPr>
-      <p:grpSpPr/>
-      <p:sp>
-        <p:nvSpPr>
-          <p:cNvPr id="2" name="Title 1"/>
-          <p:cNvSpPr>
-            <a:spLocks noGrp="1"/>
-          </p:cNvSpPr>
-          <p:nvPr>
-            <p:ph type="title"/>
-          </p:nvPr>
-        </p:nvSpPr>
-        <p:spPr/>
-        <p:txBody>
-          <a:bodyPr/>
-          <a:lstStyle/>
-          <a:p>
-            <a:pPr>
-              <a:defRPr sz="2800" b="1">
-                <a:solidFill>
-                  <a:srgbClr val="060D18"/>
-                </a:solidFill>
-              </a:defRPr>
-            </a:pPr>
-            <a:r>
-              <a:t>Recommendations &amp; Conclusion</a:t>
-            </a:r>
-          </a:p>
-        </p:txBody>
-      </p:sp>
-      <p:sp>
-        <p:nvSpPr>
-          <p:cNvPr id="3" name="Content Placeholder 2"/>
-          <p:cNvSpPr>
-            <a:spLocks noGrp="1"/>
-          </p:cNvSpPr>
-          <p:nvPr>
-            <p:ph idx="1"/>
-          </p:nvPr>
-        </p:nvSpPr>
-        <p:spPr/>
-        <p:txBody>
-          <a:bodyPr/>
-          <a:lstStyle/>
-          <a:p>
-            <a:pPr>
-              <a:spcAft>
-                <a:spcPts val="800"/>
-              </a:spcAft>
-              <a:defRPr sz="1700">
-                <a:solidFill>
-                  <a:srgbClr val="4B5563"/>
-                </a:solidFill>
-              </a:defRPr>
-            </a:pPr>
-            <a:r>
-              <a:t>Deploy publicly with HTTPS and final brand social links.</a:t>
-            </a:r>
-          </a:p>
-          <a:p>
-            <a:pPr/>
-            <a:r>
-              <a:t>Continue improving content and SEO after launch.</a:t>
-            </a:r>
-          </a:p>
-          <a:p>
-            <a:pPr/>
-            <a:r>
-              <a:t>The project meets core course outcomes and demonstrates practical CMS development.</a:t>
-            </a:r>
-          </a:p>
-        </p:txBody>
-      </p:sp>
-    </p:spTree>
-  </p:cSld>
-  <p:clrMapOvr>
-    <a:masterClrMapping/>
-  </p:clrMapOvr>
-</p:sld>
-</file>
-
-<file path=ppt/slides/slide18.xml><?xml version="1.0" encoding="utf-8"?>
-<p:sld xmlns:a="http://schemas.openxmlformats.org/drawingml/2006/main" xmlns:p="http://schemas.openxmlformats.org/presentationml/2006/main" xmlns:r="http://schemas.openxmlformats.org/officeDocument/2006/relationships">
-  <p:cSld>
-    <p:spTree>
-      <p:nvGrpSpPr>
-        <p:cNvPr id="1" name=""/>
-        <p:cNvGrpSpPr/>
-        <p:nvPr/>
-      </p:nvGrpSpPr>
-      <p:grpSpPr/>
-      <p:sp>
-        <p:nvSpPr>
-          <p:cNvPr id="2" name="Title 1"/>
-          <p:cNvSpPr>
-            <a:spLocks noGrp="1"/>
-          </p:cNvSpPr>
-          <p:nvPr>
-            <p:ph type="title"/>
-          </p:nvPr>
-        </p:nvSpPr>
-        <p:spPr/>
-        <p:txBody>
-          <a:bodyPr/>
-          <a:lstStyle/>
-          <a:p>
-            <a:pPr>
-              <a:defRPr sz="2800" b="1">
-                <a:solidFill>
-                  <a:srgbClr val="060D18"/>
-                </a:solidFill>
-              </a:defRPr>
-            </a:pPr>
-            <a:r>
-              <a:t>Assessment Alignment</a:t>
-            </a:r>
-          </a:p>
-        </p:txBody>
-      </p:sp>
-      <p:sp>
-        <p:nvSpPr>
-          <p:cNvPr id="3" name="Content Placeholder 2"/>
-          <p:cNvSpPr>
-            <a:spLocks noGrp="1"/>
-          </p:cNvSpPr>
-          <p:nvPr>
-            <p:ph idx="1"/>
-          </p:nvPr>
-        </p:nvSpPr>
-        <p:spPr/>
-        <p:txBody>
-          <a:bodyPr/>
-          <a:lstStyle/>
-          <a:p>
-            <a:pPr>
-              <a:spcAft>
-                <a:spcPts val="800"/>
-              </a:spcAft>
-              <a:defRPr sz="1500">
-                <a:solidFill>
-                  <a:srgbClr val="4B5563"/>
-                </a:solidFill>
-              </a:defRPr>
-            </a:pPr>
-            <a:r>
-              <a:t>Functionality and completeness: core pages and working form delivered.</a:t>
-            </a:r>
-          </a:p>
-          <a:p>
-            <a:pPr/>
-            <a:r>
-              <a:t>Design quality and responsiveness: consistent brand UI across devices.</a:t>
-            </a:r>
-          </a:p>
-          <a:p>
-            <a:pPr/>
-            <a:r>
-              <a:t>Structure, documentation, and demo readiness: prepared for final evaluation.</a:t>
-            </a:r>
-          </a:p>
-        </p:txBody>
-      </p:sp>
-    </p:spTree>
-  </p:cSld>
-  <p:clrMapOvr>
-    <a:masterClrMapping/>
-  </p:clrMapOvr>
-</p:sld>
-</file>
-
-<file path=ppt/slides/slide19.xml><?xml version="1.0" encoding="utf-8"?>
-<p:sld xmlns:a="http://schemas.openxmlformats.org/drawingml/2006/main" xmlns:p="http://schemas.openxmlformats.org/presentationml/2006/main" xmlns:r="http://schemas.openxmlformats.org/officeDocument/2006/relationships">
-  <p:cSld>
-    <p:spTree>
-      <p:nvGrpSpPr>
-        <p:cNvPr id="1" name=""/>
-        <p:cNvGrpSpPr/>
-        <p:nvPr/>
-      </p:nvGrpSpPr>
-      <p:grpSpPr/>
-      <p:sp>
-        <p:nvSpPr>
-          <p:cNvPr id="2" name="Title 1"/>
-          <p:cNvSpPr>
-            <a:spLocks noGrp="1"/>
-          </p:cNvSpPr>
-          <p:nvPr>
-            <p:ph type="title"/>
-          </p:nvPr>
-        </p:nvSpPr>
-        <p:spPr/>
-        <p:txBody>
-          <a:bodyPr/>
-          <a:lstStyle/>
-          <a:p>
-            <a:pPr>
-              <a:defRPr sz="2800" b="1">
-                <a:solidFill>
-                  <a:srgbClr val="060D18"/>
-                </a:solidFill>
-              </a:defRPr>
-            </a:pPr>
-            <a:r>
-              <a:t>Thank you — Q&amp;A</a:t>
-            </a:r>
-          </a:p>
-        </p:txBody>
-      </p:sp>
-      <p:sp>
-        <p:nvSpPr>
-          <p:cNvPr id="3" name="Content Placeholder 2"/>
-          <p:cNvSpPr>
-            <a:spLocks noGrp="1"/>
-          </p:cNvSpPr>
-          <p:nvPr>
-            <p:ph idx="1"/>
-          </p:nvPr>
-        </p:nvSpPr>
-        <p:spPr/>
-        <p:txBody>
-          <a:bodyPr/>
-          <a:lstStyle/>
-          <a:p>
-            <a:pPr>
-              <a:spcAft>
-                <a:spcPts val="800"/>
-              </a:spcAft>
-              <a:defRPr sz="2200">
-                <a:solidFill>
-                  <a:srgbClr val="4B5563"/>
-                </a:solidFill>
-              </a:defRPr>
-            </a:pPr>
-            <a:r>
-              <a:t>John Alexander Kamau  ·  Student No. 20-0471</a:t>
-            </a:r>
-          </a:p>
-          <a:p>
-            <a:pPr>
-              <a:spcAft>
-                <a:spcPts val="800"/>
-              </a:spcAft>
-              <a:defRPr sz="2200">
-                <a:solidFill>
-                  <a:srgbClr val="4B5563"/>
-                </a:solidFill>
-              </a:defRPr>
-            </a:pPr>
-            <a:r>
-              <a:t>I welcome your questions.</a:t>
-            </a:r>
-          </a:p>
-          <a:p>
-            <a:pPr>
-              <a:spcAft>
-                <a:spcPts val="800"/>
-              </a:spcAft>
-              <a:defRPr sz="2200">
-                <a:solidFill>
-                  <a:srgbClr val="4B5563"/>
-                </a:solidFill>
-              </a:defRPr>
-            </a:pPr>
-            <a:r>
-              <a:t>Aura Energy — student web development project (PRC 305).</a:t>
+            <a:r>
+              <a:rPr sz="1000">
+                <a:solidFill>
+                  <a:srgbClr val="7F849C"/>
+                </a:solidFill>
+                <a:latin typeface="JetBrains Mono"/>
+              </a:rPr>
+              <a:t>AURA ENERGY  |  PRC 305 WEB DEVELOPMENT PROJECT</a:t>
             </a:r>
           </a:p>
         </p:txBody>
@@ -4275,6 +4043,180 @@
       <p:grpSpPr/>
       <p:sp>
         <p:nvSpPr>
+          <p:cNvPr id="7" name="Rounded Rectangle 6"/>
+          <p:cNvSpPr/>
+          <p:nvPr/>
+        </p:nvSpPr>
+        <p:spPr>
+          <a:xfrm>
+            <a:off x="975335" y="822960"/>
+            <a:ext cx="10484857" cy="5349240"/>
+          </a:xfrm>
+          <a:prstGeom prst="roundRect">
+            <a:avLst/>
+          </a:prstGeom>
+          <a:solidFill>
+            <a:srgbClr val="313244"/>
+          </a:solidFill>
+          <a:ln w="15240">
+            <a:solidFill>
+              <a:srgbClr val="45475A"/>
+            </a:solidFill>
+          </a:ln>
+        </p:spPr>
+        <p:style>
+          <a:lnRef idx="1">
+            <a:schemeClr val="accent1"/>
+          </a:lnRef>
+          <a:fillRef idx="3">
+            <a:schemeClr val="accent1"/>
+          </a:fillRef>
+          <a:effectRef idx="2">
+            <a:schemeClr val="accent1"/>
+          </a:effectRef>
+          <a:fontRef idx="minor">
+            <a:schemeClr val="lt1"/>
+          </a:fontRef>
+        </p:style>
+        <p:txBody>
+          <a:bodyPr rtlCol="0" anchor="ctr"/>
+          <a:lstStyle/>
+          <a:p>
+            <a:pPr algn="ctr"/>
+          </a:p>
+        </p:txBody>
+      </p:sp>
+      <p:sp>
+        <p:nvSpPr>
+          <p:cNvPr id="6" name="Rectangle 5"/>
+          <p:cNvSpPr/>
+          <p:nvPr/>
+        </p:nvSpPr>
+        <p:spPr>
+          <a:xfrm>
+            <a:off x="487667" y="548640"/>
+            <a:ext cx="73150" cy="5760720"/>
+          </a:xfrm>
+          <a:prstGeom prst="rect">
+            <a:avLst/>
+          </a:prstGeom>
+          <a:solidFill>
+            <a:srgbClr val="CBA6F7"/>
+          </a:solidFill>
+          <a:ln>
+            <a:noFill/>
+          </a:ln>
+        </p:spPr>
+        <p:style>
+          <a:lnRef idx="1">
+            <a:schemeClr val="accent1"/>
+          </a:lnRef>
+          <a:fillRef idx="3">
+            <a:schemeClr val="accent1"/>
+          </a:fillRef>
+          <a:effectRef idx="2">
+            <a:schemeClr val="accent1"/>
+          </a:effectRef>
+          <a:fontRef idx="minor">
+            <a:schemeClr val="lt1"/>
+          </a:fontRef>
+        </p:style>
+        <p:txBody>
+          <a:bodyPr rtlCol="0" anchor="ctr"/>
+          <a:lstStyle/>
+          <a:p>
+            <a:pPr algn="ctr"/>
+          </a:p>
+        </p:txBody>
+      </p:sp>
+      <p:sp>
+        <p:nvSpPr>
+          <p:cNvPr id="5" name="Rectangle 4"/>
+          <p:cNvSpPr/>
+          <p:nvPr/>
+        </p:nvSpPr>
+        <p:spPr>
+          <a:xfrm>
+            <a:off x="0" y="0"/>
+            <a:ext cx="12191695" cy="1234440"/>
+          </a:xfrm>
+          <a:prstGeom prst="rect">
+            <a:avLst/>
+          </a:prstGeom>
+          <a:solidFill>
+            <a:srgbClr val="162343"/>
+          </a:solidFill>
+          <a:ln>
+            <a:noFill/>
+          </a:ln>
+        </p:spPr>
+        <p:style>
+          <a:lnRef idx="1">
+            <a:schemeClr val="accent1"/>
+          </a:lnRef>
+          <a:fillRef idx="3">
+            <a:schemeClr val="accent1"/>
+          </a:fillRef>
+          <a:effectRef idx="2">
+            <a:schemeClr val="accent1"/>
+          </a:effectRef>
+          <a:fontRef idx="minor">
+            <a:schemeClr val="lt1"/>
+          </a:fontRef>
+        </p:style>
+        <p:txBody>
+          <a:bodyPr rtlCol="0" anchor="ctr"/>
+          <a:lstStyle/>
+          <a:p>
+            <a:pPr algn="ctr"/>
+          </a:p>
+        </p:txBody>
+      </p:sp>
+      <p:sp>
+        <p:nvSpPr>
+          <p:cNvPr id="4" name="Rectangle 3"/>
+          <p:cNvSpPr/>
+          <p:nvPr/>
+        </p:nvSpPr>
+        <p:spPr>
+          <a:xfrm>
+            <a:off x="0" y="0"/>
+            <a:ext cx="12191695" cy="6858000"/>
+          </a:xfrm>
+          <a:prstGeom prst="rect">
+            <a:avLst/>
+          </a:prstGeom>
+          <a:solidFill>
+            <a:srgbClr val="1E1E2E"/>
+          </a:solidFill>
+          <a:ln>
+            <a:noFill/>
+          </a:ln>
+        </p:spPr>
+        <p:style>
+          <a:lnRef idx="1">
+            <a:schemeClr val="accent1"/>
+          </a:lnRef>
+          <a:fillRef idx="3">
+            <a:schemeClr val="accent1"/>
+          </a:fillRef>
+          <a:effectRef idx="2">
+            <a:schemeClr val="accent1"/>
+          </a:effectRef>
+          <a:fontRef idx="minor">
+            <a:schemeClr val="lt1"/>
+          </a:fontRef>
+        </p:style>
+        <p:txBody>
+          <a:bodyPr rtlCol="0" anchor="ctr"/>
+          <a:lstStyle/>
+          <a:p>
+            <a:pPr algn="ctr"/>
+          </a:p>
+        </p:txBody>
+      </p:sp>
+      <p:sp>
+        <p:nvSpPr>
           <p:cNvPr id="2" name="Title 1"/>
           <p:cNvSpPr>
             <a:spLocks noGrp="1"/>
@@ -4283,12 +4225,25 @@
             <p:ph type="title"/>
           </p:nvPr>
         </p:nvSpPr>
-        <p:spPr/>
-        <p:txBody>
-          <a:bodyPr/>
+        <p:spPr>
+          <a:xfrm>
+            <a:off x="1341086" y="1028700"/>
+          </a:xfrm>
+        </p:spPr>
+        <p:txBody>
+          <a:bodyPr wrap="square"/>
           <a:lstStyle/>
           <a:p>
             <a:pPr>
+              <a:lnSpc>
+                <a:spcPct val="125000"/>
+              </a:lnSpc>
+              <a:spcBef>
+                <a:spcPts val="0"/>
+              </a:spcBef>
+              <a:spcAft>
+                <a:spcPts val="800"/>
+              </a:spcAft>
               <a:defRPr sz="2800" b="1">
                 <a:solidFill>
                   <a:srgbClr val="060D18"/>
@@ -4296,6 +4251,12 @@
               </a:defRPr>
             </a:pPr>
             <a:r>
+              <a:rPr b="1" sz="3000">
+                <a:solidFill>
+                  <a:srgbClr val="EEF2FF"/>
+                </a:solidFill>
+                <a:latin typeface="JetBrains Mono"/>
+              </a:rPr>
               <a:t>Agenda</a:t>
             </a:r>
           </a:p>
@@ -4311,12 +4272,22 @@
             <p:ph idx="1"/>
           </p:nvPr>
         </p:nvSpPr>
-        <p:spPr/>
-        <p:txBody>
-          <a:bodyPr/>
+        <p:spPr>
+          <a:xfrm>
+            <a:off x="1341086" y="0"/>
+          </a:xfrm>
+        </p:spPr>
+        <p:txBody>
+          <a:bodyPr wrap="square"/>
           <a:lstStyle/>
           <a:p>
             <a:pPr>
+              <a:lnSpc>
+                <a:spcPct val="125000"/>
+              </a:lnSpc>
+              <a:spcBef>
+                <a:spcPts val="0"/>
+              </a:spcBef>
               <a:spcAft>
                 <a:spcPts val="800"/>
               </a:spcAft>
@@ -4327,37 +4298,179 @@
               </a:defRPr>
             </a:pPr>
             <a:r>
-              <a:t>Introduction and problem</a:t>
-            </a:r>
-          </a:p>
-          <a:p>
-            <a:pPr/>
-            <a:r>
-              <a:t>Objectives</a:t>
-            </a:r>
-          </a:p>
-          <a:p>
-            <a:pPr/>
-            <a:r>
-              <a:t>Design and user experience</a:t>
-            </a:r>
-          </a:p>
-          <a:p>
-            <a:pPr/>
-            <a:r>
-              <a:t>Technology and build approach</a:t>
-            </a:r>
-          </a:p>
-          <a:p>
-            <a:pPr/>
-            <a:r>
-              <a:t>Live demo</a:t>
-            </a:r>
-          </a:p>
-          <a:p>
-            <a:pPr/>
-            <a:r>
-              <a:t>Challenges, recommendations, and conclusion</a:t>
+              <a:rPr b="1" sz="3000">
+                <a:solidFill>
+                  <a:srgbClr val="EEF2FF"/>
+                </a:solidFill>
+                <a:latin typeface="JetBrains Mono"/>
+              </a:rPr>
+              <a:t>Project introduction and background</a:t>
+            </a:r>
+          </a:p>
+          <a:p>
+            <a:pPr>
+              <a:lnSpc>
+                <a:spcPct val="125000"/>
+              </a:lnSpc>
+              <a:spcBef>
+                <a:spcPts val="0"/>
+              </a:spcBef>
+              <a:spcAft>
+                <a:spcPts val="800"/>
+              </a:spcAft>
+            </a:pPr>
+            <a:r>
+              <a:rPr sz="1600">
+                <a:solidFill>
+                  <a:srgbClr val="CDD6F4"/>
+                </a:solidFill>
+                <a:latin typeface="JetBrains Mono"/>
+              </a:rPr>
+              <a:t>• Objectives and problem statement</a:t>
+            </a:r>
+          </a:p>
+          <a:p>
+            <a:pPr>
+              <a:lnSpc>
+                <a:spcPct val="125000"/>
+              </a:lnSpc>
+              <a:spcBef>
+                <a:spcPts val="0"/>
+              </a:spcBef>
+              <a:spcAft>
+                <a:spcPts val="800"/>
+              </a:spcAft>
+            </a:pPr>
+            <a:r>
+              <a:rPr sz="1600">
+                <a:solidFill>
+                  <a:srgbClr val="CDD6F4"/>
+                </a:solidFill>
+                <a:latin typeface="JetBrains Mono"/>
+              </a:rPr>
+              <a:t>• Design process and UI/UX considerations</a:t>
+            </a:r>
+          </a:p>
+          <a:p>
+            <a:pPr>
+              <a:lnSpc>
+                <a:spcPct val="125000"/>
+              </a:lnSpc>
+              <a:spcBef>
+                <a:spcPts val="0"/>
+              </a:spcBef>
+              <a:spcAft>
+                <a:spcPts val="800"/>
+              </a:spcAft>
+            </a:pPr>
+            <a:r>
+              <a:rPr sz="1600">
+                <a:solidFill>
+                  <a:srgbClr val="CDD6F4"/>
+                </a:solidFill>
+                <a:latin typeface="JetBrains Mono"/>
+              </a:rPr>
+              <a:t>• Development approach</a:t>
+            </a:r>
+          </a:p>
+          <a:p>
+            <a:pPr>
+              <a:lnSpc>
+                <a:spcPct val="125000"/>
+              </a:lnSpc>
+              <a:spcBef>
+                <a:spcPts val="0"/>
+              </a:spcBef>
+              <a:spcAft>
+                <a:spcPts val="800"/>
+              </a:spcAft>
+            </a:pPr>
+            <a:r>
+              <a:rPr sz="1600">
+                <a:solidFill>
+                  <a:srgbClr val="CDD6F4"/>
+                </a:solidFill>
+                <a:latin typeface="JetBrains Mono"/>
+              </a:rPr>
+              <a:t>• Challenges and solutions</a:t>
+            </a:r>
+          </a:p>
+          <a:p>
+            <a:pPr>
+              <a:lnSpc>
+                <a:spcPct val="125000"/>
+              </a:lnSpc>
+              <a:spcBef>
+                <a:spcPts val="0"/>
+              </a:spcBef>
+              <a:spcAft>
+                <a:spcPts val="800"/>
+              </a:spcAft>
+            </a:pPr>
+            <a:r>
+              <a:rPr sz="1600">
+                <a:solidFill>
+                  <a:srgbClr val="CDD6F4"/>
+                </a:solidFill>
+                <a:latin typeface="JetBrains Mono"/>
+              </a:rPr>
+              <a:t>• Live demonstration</a:t>
+            </a:r>
+          </a:p>
+          <a:p>
+            <a:pPr>
+              <a:lnSpc>
+                <a:spcPct val="125000"/>
+              </a:lnSpc>
+              <a:spcBef>
+                <a:spcPts val="0"/>
+              </a:spcBef>
+              <a:spcAft>
+                <a:spcPts val="800"/>
+              </a:spcAft>
+            </a:pPr>
+            <a:r>
+              <a:rPr sz="1600">
+                <a:solidFill>
+                  <a:srgbClr val="CDD6F4"/>
+                </a:solidFill>
+                <a:latin typeface="JetBrains Mono"/>
+              </a:rPr>
+              <a:t>• Recommendations, conclusion, and Q&amp;A</a:t>
+            </a:r>
+          </a:p>
+        </p:txBody>
+      </p:sp>
+      <p:sp>
+        <p:nvSpPr>
+          <p:cNvPr id="8" name="TextBox 7"/>
+          <p:cNvSpPr txBox="1"/>
+          <p:nvPr/>
+        </p:nvSpPr>
+        <p:spPr>
+          <a:xfrm>
+            <a:off x="1097252" y="6309360"/>
+            <a:ext cx="9997189" cy="342900"/>
+          </a:xfrm>
+          <a:prstGeom prst="rect">
+            <a:avLst/>
+          </a:prstGeom>
+          <a:noFill/>
+        </p:spPr>
+        <p:txBody>
+          <a:bodyPr wrap="none">
+            <a:spAutoFit/>
+          </a:bodyPr>
+          <a:lstStyle/>
+          <a:p>
+            <a:r>
+              <a:rPr sz="1000">
+                <a:solidFill>
+                  <a:srgbClr val="7F849C"/>
+                </a:solidFill>
+                <a:latin typeface="JetBrains Mono"/>
+              </a:rPr>
+              <a:t>AURA ENERGY  |  PRC 305 WEB DEVELOPMENT PROJECT</a:t>
             </a:r>
           </a:p>
         </p:txBody>
@@ -4382,6 +4495,180 @@
       <p:grpSpPr/>
       <p:sp>
         <p:nvSpPr>
+          <p:cNvPr id="7" name="Rounded Rectangle 6"/>
+          <p:cNvSpPr/>
+          <p:nvPr/>
+        </p:nvSpPr>
+        <p:spPr>
+          <a:xfrm>
+            <a:off x="975335" y="822960"/>
+            <a:ext cx="10484857" cy="5349240"/>
+          </a:xfrm>
+          <a:prstGeom prst="roundRect">
+            <a:avLst/>
+          </a:prstGeom>
+          <a:solidFill>
+            <a:srgbClr val="313244"/>
+          </a:solidFill>
+          <a:ln w="15240">
+            <a:solidFill>
+              <a:srgbClr val="45475A"/>
+            </a:solidFill>
+          </a:ln>
+        </p:spPr>
+        <p:style>
+          <a:lnRef idx="1">
+            <a:schemeClr val="accent1"/>
+          </a:lnRef>
+          <a:fillRef idx="3">
+            <a:schemeClr val="accent1"/>
+          </a:fillRef>
+          <a:effectRef idx="2">
+            <a:schemeClr val="accent1"/>
+          </a:effectRef>
+          <a:fontRef idx="minor">
+            <a:schemeClr val="lt1"/>
+          </a:fontRef>
+        </p:style>
+        <p:txBody>
+          <a:bodyPr rtlCol="0" anchor="ctr"/>
+          <a:lstStyle/>
+          <a:p>
+            <a:pPr algn="ctr"/>
+          </a:p>
+        </p:txBody>
+      </p:sp>
+      <p:sp>
+        <p:nvSpPr>
+          <p:cNvPr id="6" name="Rectangle 5"/>
+          <p:cNvSpPr/>
+          <p:nvPr/>
+        </p:nvSpPr>
+        <p:spPr>
+          <a:xfrm>
+            <a:off x="487667" y="548640"/>
+            <a:ext cx="73150" cy="5760720"/>
+          </a:xfrm>
+          <a:prstGeom prst="rect">
+            <a:avLst/>
+          </a:prstGeom>
+          <a:solidFill>
+            <a:srgbClr val="CBA6F7"/>
+          </a:solidFill>
+          <a:ln>
+            <a:noFill/>
+          </a:ln>
+        </p:spPr>
+        <p:style>
+          <a:lnRef idx="1">
+            <a:schemeClr val="accent1"/>
+          </a:lnRef>
+          <a:fillRef idx="3">
+            <a:schemeClr val="accent1"/>
+          </a:fillRef>
+          <a:effectRef idx="2">
+            <a:schemeClr val="accent1"/>
+          </a:effectRef>
+          <a:fontRef idx="minor">
+            <a:schemeClr val="lt1"/>
+          </a:fontRef>
+        </p:style>
+        <p:txBody>
+          <a:bodyPr rtlCol="0" anchor="ctr"/>
+          <a:lstStyle/>
+          <a:p>
+            <a:pPr algn="ctr"/>
+          </a:p>
+        </p:txBody>
+      </p:sp>
+      <p:sp>
+        <p:nvSpPr>
+          <p:cNvPr id="5" name="Rectangle 4"/>
+          <p:cNvSpPr/>
+          <p:nvPr/>
+        </p:nvSpPr>
+        <p:spPr>
+          <a:xfrm>
+            <a:off x="0" y="0"/>
+            <a:ext cx="12191695" cy="1234440"/>
+          </a:xfrm>
+          <a:prstGeom prst="rect">
+            <a:avLst/>
+          </a:prstGeom>
+          <a:solidFill>
+            <a:srgbClr val="162343"/>
+          </a:solidFill>
+          <a:ln>
+            <a:noFill/>
+          </a:ln>
+        </p:spPr>
+        <p:style>
+          <a:lnRef idx="1">
+            <a:schemeClr val="accent1"/>
+          </a:lnRef>
+          <a:fillRef idx="3">
+            <a:schemeClr val="accent1"/>
+          </a:fillRef>
+          <a:effectRef idx="2">
+            <a:schemeClr val="accent1"/>
+          </a:effectRef>
+          <a:fontRef idx="minor">
+            <a:schemeClr val="lt1"/>
+          </a:fontRef>
+        </p:style>
+        <p:txBody>
+          <a:bodyPr rtlCol="0" anchor="ctr"/>
+          <a:lstStyle/>
+          <a:p>
+            <a:pPr algn="ctr"/>
+          </a:p>
+        </p:txBody>
+      </p:sp>
+      <p:sp>
+        <p:nvSpPr>
+          <p:cNvPr id="4" name="Rectangle 3"/>
+          <p:cNvSpPr/>
+          <p:nvPr/>
+        </p:nvSpPr>
+        <p:spPr>
+          <a:xfrm>
+            <a:off x="0" y="0"/>
+            <a:ext cx="12191695" cy="6858000"/>
+          </a:xfrm>
+          <a:prstGeom prst="rect">
+            <a:avLst/>
+          </a:prstGeom>
+          <a:solidFill>
+            <a:srgbClr val="1E1E2E"/>
+          </a:solidFill>
+          <a:ln>
+            <a:noFill/>
+          </a:ln>
+        </p:spPr>
+        <p:style>
+          <a:lnRef idx="1">
+            <a:schemeClr val="accent1"/>
+          </a:lnRef>
+          <a:fillRef idx="3">
+            <a:schemeClr val="accent1"/>
+          </a:fillRef>
+          <a:effectRef idx="2">
+            <a:schemeClr val="accent1"/>
+          </a:effectRef>
+          <a:fontRef idx="minor">
+            <a:schemeClr val="lt1"/>
+          </a:fontRef>
+        </p:style>
+        <p:txBody>
+          <a:bodyPr rtlCol="0" anchor="ctr"/>
+          <a:lstStyle/>
+          <a:p>
+            <a:pPr algn="ctr"/>
+          </a:p>
+        </p:txBody>
+      </p:sp>
+      <p:sp>
+        <p:nvSpPr>
           <p:cNvPr id="2" name="Title 1"/>
           <p:cNvSpPr>
             <a:spLocks noGrp="1"/>
@@ -4390,12 +4677,25 @@
             <p:ph type="title"/>
           </p:nvPr>
         </p:nvSpPr>
-        <p:spPr/>
-        <p:txBody>
-          <a:bodyPr/>
+        <p:spPr>
+          <a:xfrm>
+            <a:off x="1341086" y="1028700"/>
+          </a:xfrm>
+        </p:spPr>
+        <p:txBody>
+          <a:bodyPr wrap="square"/>
           <a:lstStyle/>
           <a:p>
             <a:pPr>
+              <a:lnSpc>
+                <a:spcPct val="125000"/>
+              </a:lnSpc>
+              <a:spcBef>
+                <a:spcPts val="0"/>
+              </a:spcBef>
+              <a:spcAft>
+                <a:spcPts val="800"/>
+              </a:spcAft>
               <a:defRPr sz="2800" b="1">
                 <a:solidFill>
                   <a:srgbClr val="060D18"/>
@@ -4403,7 +4703,13 @@
               </a:defRPr>
             </a:pPr>
             <a:r>
-              <a:t>Project Introduction</a:t>
+              <a:rPr b="1" sz="3000">
+                <a:solidFill>
+                  <a:srgbClr val="EEF2FF"/>
+                </a:solidFill>
+                <a:latin typeface="JetBrains Mono"/>
+              </a:rPr>
+              <a:t>Project Introduction &amp; Background</a:t>
             </a:r>
           </a:p>
         </p:txBody>
@@ -4418,12 +4724,22 @@
             <p:ph idx="1"/>
           </p:nvPr>
         </p:nvSpPr>
-        <p:spPr/>
-        <p:txBody>
-          <a:bodyPr/>
+        <p:spPr>
+          <a:xfrm>
+            <a:off x="1341086" y="0"/>
+          </a:xfrm>
+        </p:spPr>
+        <p:txBody>
+          <a:bodyPr wrap="square"/>
           <a:lstStyle/>
           <a:p>
             <a:pPr>
+              <a:lnSpc>
+                <a:spcPct val="125000"/>
+              </a:lnSpc>
+              <a:spcBef>
+                <a:spcPts val="0"/>
+              </a:spcBef>
               <a:spcAft>
                 <a:spcPts val="800"/>
               </a:spcAft>
@@ -4434,19 +4750,91 @@
               </a:defRPr>
             </a:pPr>
             <a:r>
-              <a:t>Aura Energy is a premium functional beverage concept for East African professionals and creators.</a:t>
-            </a:r>
-          </a:p>
-          <a:p>
-            <a:pPr/>
-            <a:r>
-              <a:t>The website builds trust, explains products, and makes it easy for users to contact the brand.</a:t>
-            </a:r>
-          </a:p>
-          <a:p>
-            <a:pPr/>
-            <a:r>
-              <a:t>Goal: a clear, mobile-friendly digital presence.</a:t>
+              <a:rPr sz="1700">
+                <a:solidFill>
+                  <a:srgbClr val="CDD6F4"/>
+                </a:solidFill>
+                <a:latin typeface="JetBrains Mono"/>
+              </a:rPr>
+              <a:t>Aura Energy is a premium functional beverage concept for professionals, creators, and shift workers in East Africa.</a:t>
+            </a:r>
+          </a:p>
+          <a:p>
+            <a:pPr>
+              <a:lnSpc>
+                <a:spcPct val="125000"/>
+              </a:lnSpc>
+              <a:spcBef>
+                <a:spcPts val="0"/>
+              </a:spcBef>
+              <a:spcAft>
+                <a:spcPts val="800"/>
+              </a:spcAft>
+            </a:pPr>
+            <a:r>
+              <a:rPr sz="1600">
+                <a:solidFill>
+                  <a:srgbClr val="CDD6F4"/>
+                </a:solidFill>
+                <a:latin typeface="JetBrains Mono"/>
+              </a:rPr>
+              <a:t>• The website was designed to build trust, communicate product value, and provide a clear contact path.</a:t>
+            </a:r>
+          </a:p>
+          <a:p>
+            <a:pPr>
+              <a:lnSpc>
+                <a:spcPct val="125000"/>
+              </a:lnSpc>
+              <a:spcBef>
+                <a:spcPts val="0"/>
+              </a:spcBef>
+              <a:spcAft>
+                <a:spcPts val="800"/>
+              </a:spcAft>
+            </a:pPr>
+            <a:r>
+              <a:rPr sz="1600">
+                <a:solidFill>
+                  <a:srgbClr val="CDD6F4"/>
+                </a:solidFill>
+                <a:latin typeface="JetBrains Mono"/>
+              </a:rPr>
+              <a:t>• This project applies the full CMS workflow from planning to implementation and presentation.</a:t>
+            </a:r>
+          </a:p>
+        </p:txBody>
+      </p:sp>
+      <p:sp>
+        <p:nvSpPr>
+          <p:cNvPr id="8" name="TextBox 7"/>
+          <p:cNvSpPr txBox="1"/>
+          <p:nvPr/>
+        </p:nvSpPr>
+        <p:spPr>
+          <a:xfrm>
+            <a:off x="1097252" y="6309360"/>
+            <a:ext cx="9997189" cy="342900"/>
+          </a:xfrm>
+          <a:prstGeom prst="rect">
+            <a:avLst/>
+          </a:prstGeom>
+          <a:noFill/>
+        </p:spPr>
+        <p:txBody>
+          <a:bodyPr wrap="none">
+            <a:spAutoFit/>
+          </a:bodyPr>
+          <a:lstStyle/>
+          <a:p>
+            <a:r>
+              <a:rPr sz="1000">
+                <a:solidFill>
+                  <a:srgbClr val="7F849C"/>
+                </a:solidFill>
+                <a:latin typeface="JetBrains Mono"/>
+              </a:rPr>
+              <a:t>AURA ENERGY  |  PRC 305 WEB DEVELOPMENT PROJECT</a:t>
             </a:r>
           </a:p>
         </p:txBody>
@@ -4471,6 +4859,180 @@
       <p:grpSpPr/>
       <p:sp>
         <p:nvSpPr>
+          <p:cNvPr id="7" name="Rounded Rectangle 6"/>
+          <p:cNvSpPr/>
+          <p:nvPr/>
+        </p:nvSpPr>
+        <p:spPr>
+          <a:xfrm>
+            <a:off x="975335" y="822960"/>
+            <a:ext cx="10484857" cy="5349240"/>
+          </a:xfrm>
+          <a:prstGeom prst="roundRect">
+            <a:avLst/>
+          </a:prstGeom>
+          <a:solidFill>
+            <a:srgbClr val="313244"/>
+          </a:solidFill>
+          <a:ln w="15240">
+            <a:solidFill>
+              <a:srgbClr val="45475A"/>
+            </a:solidFill>
+          </a:ln>
+        </p:spPr>
+        <p:style>
+          <a:lnRef idx="1">
+            <a:schemeClr val="accent1"/>
+          </a:lnRef>
+          <a:fillRef idx="3">
+            <a:schemeClr val="accent1"/>
+          </a:fillRef>
+          <a:effectRef idx="2">
+            <a:schemeClr val="accent1"/>
+          </a:effectRef>
+          <a:fontRef idx="minor">
+            <a:schemeClr val="lt1"/>
+          </a:fontRef>
+        </p:style>
+        <p:txBody>
+          <a:bodyPr rtlCol="0" anchor="ctr"/>
+          <a:lstStyle/>
+          <a:p>
+            <a:pPr algn="ctr"/>
+          </a:p>
+        </p:txBody>
+      </p:sp>
+      <p:sp>
+        <p:nvSpPr>
+          <p:cNvPr id="6" name="Rectangle 5"/>
+          <p:cNvSpPr/>
+          <p:nvPr/>
+        </p:nvSpPr>
+        <p:spPr>
+          <a:xfrm>
+            <a:off x="487667" y="548640"/>
+            <a:ext cx="73150" cy="5760720"/>
+          </a:xfrm>
+          <a:prstGeom prst="rect">
+            <a:avLst/>
+          </a:prstGeom>
+          <a:solidFill>
+            <a:srgbClr val="CBA6F7"/>
+          </a:solidFill>
+          <a:ln>
+            <a:noFill/>
+          </a:ln>
+        </p:spPr>
+        <p:style>
+          <a:lnRef idx="1">
+            <a:schemeClr val="accent1"/>
+          </a:lnRef>
+          <a:fillRef idx="3">
+            <a:schemeClr val="accent1"/>
+          </a:fillRef>
+          <a:effectRef idx="2">
+            <a:schemeClr val="accent1"/>
+          </a:effectRef>
+          <a:fontRef idx="minor">
+            <a:schemeClr val="lt1"/>
+          </a:fontRef>
+        </p:style>
+        <p:txBody>
+          <a:bodyPr rtlCol="0" anchor="ctr"/>
+          <a:lstStyle/>
+          <a:p>
+            <a:pPr algn="ctr"/>
+          </a:p>
+        </p:txBody>
+      </p:sp>
+      <p:sp>
+        <p:nvSpPr>
+          <p:cNvPr id="5" name="Rectangle 4"/>
+          <p:cNvSpPr/>
+          <p:nvPr/>
+        </p:nvSpPr>
+        <p:spPr>
+          <a:xfrm>
+            <a:off x="0" y="0"/>
+            <a:ext cx="12191695" cy="1234440"/>
+          </a:xfrm>
+          <a:prstGeom prst="rect">
+            <a:avLst/>
+          </a:prstGeom>
+          <a:solidFill>
+            <a:srgbClr val="162343"/>
+          </a:solidFill>
+          <a:ln>
+            <a:noFill/>
+          </a:ln>
+        </p:spPr>
+        <p:style>
+          <a:lnRef idx="1">
+            <a:schemeClr val="accent1"/>
+          </a:lnRef>
+          <a:fillRef idx="3">
+            <a:schemeClr val="accent1"/>
+          </a:fillRef>
+          <a:effectRef idx="2">
+            <a:schemeClr val="accent1"/>
+          </a:effectRef>
+          <a:fontRef idx="minor">
+            <a:schemeClr val="lt1"/>
+          </a:fontRef>
+        </p:style>
+        <p:txBody>
+          <a:bodyPr rtlCol="0" anchor="ctr"/>
+          <a:lstStyle/>
+          <a:p>
+            <a:pPr algn="ctr"/>
+          </a:p>
+        </p:txBody>
+      </p:sp>
+      <p:sp>
+        <p:nvSpPr>
+          <p:cNvPr id="4" name="Rectangle 3"/>
+          <p:cNvSpPr/>
+          <p:nvPr/>
+        </p:nvSpPr>
+        <p:spPr>
+          <a:xfrm>
+            <a:off x="0" y="0"/>
+            <a:ext cx="12191695" cy="6858000"/>
+          </a:xfrm>
+          <a:prstGeom prst="rect">
+            <a:avLst/>
+          </a:prstGeom>
+          <a:solidFill>
+            <a:srgbClr val="1E1E2E"/>
+          </a:solidFill>
+          <a:ln>
+            <a:noFill/>
+          </a:ln>
+        </p:spPr>
+        <p:style>
+          <a:lnRef idx="1">
+            <a:schemeClr val="accent1"/>
+          </a:lnRef>
+          <a:fillRef idx="3">
+            <a:schemeClr val="accent1"/>
+          </a:fillRef>
+          <a:effectRef idx="2">
+            <a:schemeClr val="accent1"/>
+          </a:effectRef>
+          <a:fontRef idx="minor">
+            <a:schemeClr val="lt1"/>
+          </a:fontRef>
+        </p:style>
+        <p:txBody>
+          <a:bodyPr rtlCol="0" anchor="ctr"/>
+          <a:lstStyle/>
+          <a:p>
+            <a:pPr algn="ctr"/>
+          </a:p>
+        </p:txBody>
+      </p:sp>
+      <p:sp>
+        <p:nvSpPr>
           <p:cNvPr id="2" name="Title 1"/>
           <p:cNvSpPr>
             <a:spLocks noGrp="1"/>
@@ -4479,12 +5041,25 @@
             <p:ph type="title"/>
           </p:nvPr>
         </p:nvSpPr>
-        <p:spPr/>
-        <p:txBody>
-          <a:bodyPr/>
+        <p:spPr>
+          <a:xfrm>
+            <a:off x="1341086" y="1028700"/>
+          </a:xfrm>
+        </p:spPr>
+        <p:txBody>
+          <a:bodyPr wrap="square"/>
           <a:lstStyle/>
           <a:p>
             <a:pPr>
+              <a:lnSpc>
+                <a:spcPct val="125000"/>
+              </a:lnSpc>
+              <a:spcBef>
+                <a:spcPts val="0"/>
+              </a:spcBef>
+              <a:spcAft>
+                <a:spcPts val="800"/>
+              </a:spcAft>
               <a:defRPr sz="2800" b="1">
                 <a:solidFill>
                   <a:srgbClr val="060D18"/>
@@ -4492,7 +5067,13 @@
               </a:defRPr>
             </a:pPr>
             <a:r>
-              <a:t>Problem Statement</a:t>
+              <a:rPr b="1" sz="3000">
+                <a:solidFill>
+                  <a:srgbClr val="EEF2FF"/>
+                </a:solidFill>
+                <a:latin typeface="JetBrains Mono"/>
+              </a:rPr>
+              <a:t>Objectives &amp; Problem Statement</a:t>
             </a:r>
           </a:p>
         </p:txBody>
@@ -4507,12 +5088,22 @@
             <p:ph idx="1"/>
           </p:nvPr>
         </p:nvSpPr>
-        <p:spPr/>
-        <p:txBody>
-          <a:bodyPr/>
+        <p:spPr>
+          <a:xfrm>
+            <a:off x="1341086" y="0"/>
+          </a:xfrm>
+        </p:spPr>
+        <p:txBody>
+          <a:bodyPr wrap="square"/>
           <a:lstStyle/>
           <a:p>
             <a:pPr>
+              <a:lnSpc>
+                <a:spcPct val="125000"/>
+              </a:lnSpc>
+              <a:spcBef>
+                <a:spcPts val="0"/>
+              </a:spcBef>
               <a:spcAft>
                 <a:spcPts val="800"/>
               </a:spcAft>
@@ -4523,19 +5114,113 @@
               </a:defRPr>
             </a:pPr>
             <a:r>
-              <a:t>Without a strong website, new brands look less credible.</a:t>
-            </a:r>
-          </a:p>
-          <a:p>
-            <a:pPr/>
-            <a:r>
-              <a:t>Users need product clarity, easy navigation, and quick contact options.</a:t>
-            </a:r>
-          </a:p>
-          <a:p>
-            <a:pPr/>
-            <a:r>
-              <a:t>This project solves that through a structured, responsive WordPress site.</a:t>
+              <a:rPr sz="1700">
+                <a:solidFill>
+                  <a:srgbClr val="CDD6F4"/>
+                </a:solidFill>
+                <a:latin typeface="JetBrains Mono"/>
+              </a:rPr>
+              <a:t>Problem: without a strong website, emerging brands lose credibility and user trust quickly.</a:t>
+            </a:r>
+          </a:p>
+          <a:p>
+            <a:pPr>
+              <a:lnSpc>
+                <a:spcPct val="125000"/>
+              </a:lnSpc>
+              <a:spcBef>
+                <a:spcPts val="0"/>
+              </a:spcBef>
+              <a:spcAft>
+                <a:spcPts val="800"/>
+              </a:spcAft>
+            </a:pPr>
+            <a:r>
+              <a:rPr sz="1600">
+                <a:solidFill>
+                  <a:srgbClr val="CDD6F4"/>
+                </a:solidFill>
+                <a:latin typeface="JetBrains Mono"/>
+              </a:rPr>
+              <a:t>• Objective 1: build a complete WordPress site with Home, About, Products, and Contact pages.</a:t>
+            </a:r>
+          </a:p>
+          <a:p>
+            <a:pPr>
+              <a:lnSpc>
+                <a:spcPct val="125000"/>
+              </a:lnSpc>
+              <a:spcBef>
+                <a:spcPts val="0"/>
+              </a:spcBef>
+              <a:spcAft>
+                <a:spcPts val="800"/>
+              </a:spcAft>
+            </a:pPr>
+            <a:r>
+              <a:rPr sz="1600">
+                <a:solidFill>
+                  <a:srgbClr val="CDD6F4"/>
+                </a:solidFill>
+                <a:latin typeface="JetBrains Mono"/>
+              </a:rPr>
+              <a:t>• Objective 2: deliver responsive, user-centered navigation and content flow.</a:t>
+            </a:r>
+          </a:p>
+          <a:p>
+            <a:pPr>
+              <a:lnSpc>
+                <a:spcPct val="125000"/>
+              </a:lnSpc>
+              <a:spcBef>
+                <a:spcPts val="0"/>
+              </a:spcBef>
+              <a:spcAft>
+                <a:spcPts val="800"/>
+              </a:spcAft>
+            </a:pPr>
+            <a:r>
+              <a:rPr sz="1600">
+                <a:solidFill>
+                  <a:srgbClr val="CDD6F4"/>
+                </a:solidFill>
+                <a:latin typeface="JetBrains Mono"/>
+              </a:rPr>
+              <a:t>• Objective 3: implement a working contact form with validation and notification.</a:t>
+            </a:r>
+          </a:p>
+        </p:txBody>
+      </p:sp>
+      <p:sp>
+        <p:nvSpPr>
+          <p:cNvPr id="8" name="TextBox 7"/>
+          <p:cNvSpPr txBox="1"/>
+          <p:nvPr/>
+        </p:nvSpPr>
+        <p:spPr>
+          <a:xfrm>
+            <a:off x="1097252" y="6309360"/>
+            <a:ext cx="9997189" cy="342900"/>
+          </a:xfrm>
+          <a:prstGeom prst="rect">
+            <a:avLst/>
+          </a:prstGeom>
+          <a:noFill/>
+        </p:spPr>
+        <p:txBody>
+          <a:bodyPr wrap="none">
+            <a:spAutoFit/>
+          </a:bodyPr>
+          <a:lstStyle/>
+          <a:p>
+            <a:r>
+              <a:rPr sz="1000">
+                <a:solidFill>
+                  <a:srgbClr val="7F849C"/>
+                </a:solidFill>
+                <a:latin typeface="JetBrains Mono"/>
+              </a:rPr>
+              <a:t>AURA ENERGY  |  PRC 305 WEB DEVELOPMENT PROJECT</a:t>
             </a:r>
           </a:p>
         </p:txBody>
@@ -4560,6 +5245,180 @@
       <p:grpSpPr/>
       <p:sp>
         <p:nvSpPr>
+          <p:cNvPr id="7" name="Rounded Rectangle 6"/>
+          <p:cNvSpPr/>
+          <p:nvPr/>
+        </p:nvSpPr>
+        <p:spPr>
+          <a:xfrm>
+            <a:off x="975335" y="822960"/>
+            <a:ext cx="10484857" cy="5349240"/>
+          </a:xfrm>
+          <a:prstGeom prst="roundRect">
+            <a:avLst/>
+          </a:prstGeom>
+          <a:solidFill>
+            <a:srgbClr val="313244"/>
+          </a:solidFill>
+          <a:ln w="15240">
+            <a:solidFill>
+              <a:srgbClr val="45475A"/>
+            </a:solidFill>
+          </a:ln>
+        </p:spPr>
+        <p:style>
+          <a:lnRef idx="1">
+            <a:schemeClr val="accent1"/>
+          </a:lnRef>
+          <a:fillRef idx="3">
+            <a:schemeClr val="accent1"/>
+          </a:fillRef>
+          <a:effectRef idx="2">
+            <a:schemeClr val="accent1"/>
+          </a:effectRef>
+          <a:fontRef idx="minor">
+            <a:schemeClr val="lt1"/>
+          </a:fontRef>
+        </p:style>
+        <p:txBody>
+          <a:bodyPr rtlCol="0" anchor="ctr"/>
+          <a:lstStyle/>
+          <a:p>
+            <a:pPr algn="ctr"/>
+          </a:p>
+        </p:txBody>
+      </p:sp>
+      <p:sp>
+        <p:nvSpPr>
+          <p:cNvPr id="6" name="Rectangle 5"/>
+          <p:cNvSpPr/>
+          <p:nvPr/>
+        </p:nvSpPr>
+        <p:spPr>
+          <a:xfrm>
+            <a:off x="487667" y="548640"/>
+            <a:ext cx="73150" cy="5760720"/>
+          </a:xfrm>
+          <a:prstGeom prst="rect">
+            <a:avLst/>
+          </a:prstGeom>
+          <a:solidFill>
+            <a:srgbClr val="CBA6F7"/>
+          </a:solidFill>
+          <a:ln>
+            <a:noFill/>
+          </a:ln>
+        </p:spPr>
+        <p:style>
+          <a:lnRef idx="1">
+            <a:schemeClr val="accent1"/>
+          </a:lnRef>
+          <a:fillRef idx="3">
+            <a:schemeClr val="accent1"/>
+          </a:fillRef>
+          <a:effectRef idx="2">
+            <a:schemeClr val="accent1"/>
+          </a:effectRef>
+          <a:fontRef idx="minor">
+            <a:schemeClr val="lt1"/>
+          </a:fontRef>
+        </p:style>
+        <p:txBody>
+          <a:bodyPr rtlCol="0" anchor="ctr"/>
+          <a:lstStyle/>
+          <a:p>
+            <a:pPr algn="ctr"/>
+          </a:p>
+        </p:txBody>
+      </p:sp>
+      <p:sp>
+        <p:nvSpPr>
+          <p:cNvPr id="5" name="Rectangle 4"/>
+          <p:cNvSpPr/>
+          <p:nvPr/>
+        </p:nvSpPr>
+        <p:spPr>
+          <a:xfrm>
+            <a:off x="0" y="0"/>
+            <a:ext cx="12191695" cy="1234440"/>
+          </a:xfrm>
+          <a:prstGeom prst="rect">
+            <a:avLst/>
+          </a:prstGeom>
+          <a:solidFill>
+            <a:srgbClr val="162343"/>
+          </a:solidFill>
+          <a:ln>
+            <a:noFill/>
+          </a:ln>
+        </p:spPr>
+        <p:style>
+          <a:lnRef idx="1">
+            <a:schemeClr val="accent1"/>
+          </a:lnRef>
+          <a:fillRef idx="3">
+            <a:schemeClr val="accent1"/>
+          </a:fillRef>
+          <a:effectRef idx="2">
+            <a:schemeClr val="accent1"/>
+          </a:effectRef>
+          <a:fontRef idx="minor">
+            <a:schemeClr val="lt1"/>
+          </a:fontRef>
+        </p:style>
+        <p:txBody>
+          <a:bodyPr rtlCol="0" anchor="ctr"/>
+          <a:lstStyle/>
+          <a:p>
+            <a:pPr algn="ctr"/>
+          </a:p>
+        </p:txBody>
+      </p:sp>
+      <p:sp>
+        <p:nvSpPr>
+          <p:cNvPr id="4" name="Rectangle 3"/>
+          <p:cNvSpPr/>
+          <p:nvPr/>
+        </p:nvSpPr>
+        <p:spPr>
+          <a:xfrm>
+            <a:off x="0" y="0"/>
+            <a:ext cx="12191695" cy="6858000"/>
+          </a:xfrm>
+          <a:prstGeom prst="rect">
+            <a:avLst/>
+          </a:prstGeom>
+          <a:solidFill>
+            <a:srgbClr val="1E1E2E"/>
+          </a:solidFill>
+          <a:ln>
+            <a:noFill/>
+          </a:ln>
+        </p:spPr>
+        <p:style>
+          <a:lnRef idx="1">
+            <a:schemeClr val="accent1"/>
+          </a:lnRef>
+          <a:fillRef idx="3">
+            <a:schemeClr val="accent1"/>
+          </a:fillRef>
+          <a:effectRef idx="2">
+            <a:schemeClr val="accent1"/>
+          </a:effectRef>
+          <a:fontRef idx="minor">
+            <a:schemeClr val="lt1"/>
+          </a:fontRef>
+        </p:style>
+        <p:txBody>
+          <a:bodyPr rtlCol="0" anchor="ctr"/>
+          <a:lstStyle/>
+          <a:p>
+            <a:pPr algn="ctr"/>
+          </a:p>
+        </p:txBody>
+      </p:sp>
+      <p:sp>
+        <p:nvSpPr>
           <p:cNvPr id="2" name="Title 1"/>
           <p:cNvSpPr>
             <a:spLocks noGrp="1"/>
@@ -4568,12 +5427,25 @@
             <p:ph type="title"/>
           </p:nvPr>
         </p:nvSpPr>
-        <p:spPr/>
-        <p:txBody>
-          <a:bodyPr/>
+        <p:spPr>
+          <a:xfrm>
+            <a:off x="1341086" y="1028700"/>
+          </a:xfrm>
+        </p:spPr>
+        <p:txBody>
+          <a:bodyPr wrap="square"/>
           <a:lstStyle/>
           <a:p>
             <a:pPr>
+              <a:lnSpc>
+                <a:spcPct val="125000"/>
+              </a:lnSpc>
+              <a:spcBef>
+                <a:spcPts val="0"/>
+              </a:spcBef>
+              <a:spcAft>
+                <a:spcPts val="800"/>
+              </a:spcAft>
               <a:defRPr sz="2800" b="1">
                 <a:solidFill>
                   <a:srgbClr val="060D18"/>
@@ -4581,7 +5453,13 @@
               </a:defRPr>
             </a:pPr>
             <a:r>
-              <a:t>Objectives</a:t>
+              <a:rPr b="1" sz="3000">
+                <a:solidFill>
+                  <a:srgbClr val="EEF2FF"/>
+                </a:solidFill>
+                <a:latin typeface="JetBrains Mono"/>
+              </a:rPr>
+              <a:t>Design Process &amp; UI/UX</a:t>
             </a:r>
           </a:p>
         </p:txBody>
@@ -4596,12 +5474,22 @@
             <p:ph idx="1"/>
           </p:nvPr>
         </p:nvSpPr>
-        <p:spPr/>
-        <p:txBody>
-          <a:bodyPr/>
+        <p:spPr>
+          <a:xfrm>
+            <a:off x="1341086" y="0"/>
+          </a:xfrm>
+        </p:spPr>
+        <p:txBody>
+          <a:bodyPr wrap="square"/>
           <a:lstStyle/>
           <a:p>
             <a:pPr>
+              <a:lnSpc>
+                <a:spcPct val="125000"/>
+              </a:lnSpc>
+              <a:spcBef>
+                <a:spcPts val="0"/>
+              </a:spcBef>
               <a:spcAft>
                 <a:spcPts val="800"/>
               </a:spcAft>
@@ -4612,19 +5500,91 @@
               </a:defRPr>
             </a:pPr>
             <a:r>
-              <a:t>Build a complete WordPress site: Home, About, Products, Contact.</a:t>
-            </a:r>
-          </a:p>
-          <a:p>
-            <a:pPr/>
-            <a:r>
-              <a:t>Add a working contact form with validation and feedback.</a:t>
-            </a:r>
-          </a:p>
-          <a:p>
-            <a:pPr/>
-            <a:r>
-              <a:t>Integrate social channels and ensure responsive design.</a:t>
+              <a:rPr sz="1700">
+                <a:solidFill>
+                  <a:srgbClr val="CDD6F4"/>
+                </a:solidFill>
+                <a:latin typeface="JetBrains Mono"/>
+              </a:rPr>
+              <a:t>Built a consistent visual identity across typography, spacing, color, and imagery.</a:t>
+            </a:r>
+          </a:p>
+          <a:p>
+            <a:pPr>
+              <a:lnSpc>
+                <a:spcPct val="125000"/>
+              </a:lnSpc>
+              <a:spcBef>
+                <a:spcPts val="0"/>
+              </a:spcBef>
+              <a:spcAft>
+                <a:spcPts val="800"/>
+              </a:spcAft>
+            </a:pPr>
+            <a:r>
+              <a:rPr sz="1600">
+                <a:solidFill>
+                  <a:srgbClr val="CDD6F4"/>
+                </a:solidFill>
+                <a:latin typeface="JetBrains Mono"/>
+              </a:rPr>
+              <a:t>• Structured each page for quick scanning: brand context, offer clarity, and clear call-to-action.</a:t>
+            </a:r>
+          </a:p>
+          <a:p>
+            <a:pPr>
+              <a:lnSpc>
+                <a:spcPct val="125000"/>
+              </a:lnSpc>
+              <a:spcBef>
+                <a:spcPts val="0"/>
+              </a:spcBef>
+              <a:spcAft>
+                <a:spcPts val="800"/>
+              </a:spcAft>
+            </a:pPr>
+            <a:r>
+              <a:rPr sz="1600">
+                <a:solidFill>
+                  <a:srgbClr val="CDD6F4"/>
+                </a:solidFill>
+                <a:latin typeface="JetBrains Mono"/>
+              </a:rPr>
+              <a:t>• Optimized for usability on desktop, tablet, and mobile.</a:t>
+            </a:r>
+          </a:p>
+        </p:txBody>
+      </p:sp>
+      <p:sp>
+        <p:nvSpPr>
+          <p:cNvPr id="8" name="TextBox 7"/>
+          <p:cNvSpPr txBox="1"/>
+          <p:nvPr/>
+        </p:nvSpPr>
+        <p:spPr>
+          <a:xfrm>
+            <a:off x="1097252" y="6309360"/>
+            <a:ext cx="9997189" cy="342900"/>
+          </a:xfrm>
+          <a:prstGeom prst="rect">
+            <a:avLst/>
+          </a:prstGeom>
+          <a:noFill/>
+        </p:spPr>
+        <p:txBody>
+          <a:bodyPr wrap="none">
+            <a:spAutoFit/>
+          </a:bodyPr>
+          <a:lstStyle/>
+          <a:p>
+            <a:r>
+              <a:rPr sz="1000">
+                <a:solidFill>
+                  <a:srgbClr val="7F849C"/>
+                </a:solidFill>
+                <a:latin typeface="JetBrains Mono"/>
+              </a:rPr>
+              <a:t>AURA ENERGY  |  PRC 305 WEB DEVELOPMENT PROJECT</a:t>
             </a:r>
           </a:p>
         </p:txBody>
@@ -4649,14 +5609,188 @@
       <p:grpSpPr/>
       <p:sp>
         <p:nvSpPr>
+          <p:cNvPr id="7" name="Rounded Rectangle 6"/>
+          <p:cNvSpPr/>
+          <p:nvPr/>
+        </p:nvSpPr>
+        <p:spPr>
+          <a:xfrm>
+            <a:off x="975335" y="822960"/>
+            <a:ext cx="10484857" cy="5349240"/>
+          </a:xfrm>
+          <a:prstGeom prst="roundRect">
+            <a:avLst/>
+          </a:prstGeom>
+          <a:solidFill>
+            <a:srgbClr val="313244"/>
+          </a:solidFill>
+          <a:ln w="15240">
+            <a:solidFill>
+              <a:srgbClr val="45475A"/>
+            </a:solidFill>
+          </a:ln>
+        </p:spPr>
+        <p:style>
+          <a:lnRef idx="1">
+            <a:schemeClr val="accent1"/>
+          </a:lnRef>
+          <a:fillRef idx="3">
+            <a:schemeClr val="accent1"/>
+          </a:fillRef>
+          <a:effectRef idx="2">
+            <a:schemeClr val="accent1"/>
+          </a:effectRef>
+          <a:fontRef idx="minor">
+            <a:schemeClr val="lt1"/>
+          </a:fontRef>
+        </p:style>
+        <p:txBody>
+          <a:bodyPr rtlCol="0" anchor="ctr"/>
+          <a:lstStyle/>
+          <a:p>
+            <a:pPr algn="ctr"/>
+          </a:p>
+        </p:txBody>
+      </p:sp>
+      <p:sp>
+        <p:nvSpPr>
+          <p:cNvPr id="6" name="Rectangle 5"/>
+          <p:cNvSpPr/>
+          <p:nvPr/>
+        </p:nvSpPr>
+        <p:spPr>
+          <a:xfrm>
+            <a:off x="487667" y="548640"/>
+            <a:ext cx="73150" cy="5760720"/>
+          </a:xfrm>
+          <a:prstGeom prst="rect">
+            <a:avLst/>
+          </a:prstGeom>
+          <a:solidFill>
+            <a:srgbClr val="CBA6F7"/>
+          </a:solidFill>
+          <a:ln>
+            <a:noFill/>
+          </a:ln>
+        </p:spPr>
+        <p:style>
+          <a:lnRef idx="1">
+            <a:schemeClr val="accent1"/>
+          </a:lnRef>
+          <a:fillRef idx="3">
+            <a:schemeClr val="accent1"/>
+          </a:fillRef>
+          <a:effectRef idx="2">
+            <a:schemeClr val="accent1"/>
+          </a:effectRef>
+          <a:fontRef idx="minor">
+            <a:schemeClr val="lt1"/>
+          </a:fontRef>
+        </p:style>
+        <p:txBody>
+          <a:bodyPr rtlCol="0" anchor="ctr"/>
+          <a:lstStyle/>
+          <a:p>
+            <a:pPr algn="ctr"/>
+          </a:p>
+        </p:txBody>
+      </p:sp>
+      <p:sp>
+        <p:nvSpPr>
+          <p:cNvPr id="5" name="Rectangle 4"/>
+          <p:cNvSpPr/>
+          <p:nvPr/>
+        </p:nvSpPr>
+        <p:spPr>
+          <a:xfrm>
+            <a:off x="0" y="0"/>
+            <a:ext cx="12191695" cy="1234440"/>
+          </a:xfrm>
+          <a:prstGeom prst="rect">
+            <a:avLst/>
+          </a:prstGeom>
+          <a:solidFill>
+            <a:srgbClr val="162343"/>
+          </a:solidFill>
+          <a:ln>
+            <a:noFill/>
+          </a:ln>
+        </p:spPr>
+        <p:style>
+          <a:lnRef idx="1">
+            <a:schemeClr val="accent1"/>
+          </a:lnRef>
+          <a:fillRef idx="3">
+            <a:schemeClr val="accent1"/>
+          </a:fillRef>
+          <a:effectRef idx="2">
+            <a:schemeClr val="accent1"/>
+          </a:effectRef>
+          <a:fontRef idx="minor">
+            <a:schemeClr val="lt1"/>
+          </a:fontRef>
+        </p:style>
+        <p:txBody>
+          <a:bodyPr rtlCol="0" anchor="ctr"/>
+          <a:lstStyle/>
+          <a:p>
+            <a:pPr algn="ctr"/>
+          </a:p>
+        </p:txBody>
+      </p:sp>
+      <p:sp>
+        <p:nvSpPr>
+          <p:cNvPr id="4" name="Rectangle 3"/>
+          <p:cNvSpPr/>
+          <p:nvPr/>
+        </p:nvSpPr>
+        <p:spPr>
+          <a:xfrm>
+            <a:off x="0" y="0"/>
+            <a:ext cx="12191695" cy="6858000"/>
+          </a:xfrm>
+          <a:prstGeom prst="rect">
+            <a:avLst/>
+          </a:prstGeom>
+          <a:solidFill>
+            <a:srgbClr val="1E1E2E"/>
+          </a:solidFill>
+          <a:ln>
+            <a:noFill/>
+          </a:ln>
+        </p:spPr>
+        <p:style>
+          <a:lnRef idx="1">
+            <a:schemeClr val="accent1"/>
+          </a:lnRef>
+          <a:fillRef idx="3">
+            <a:schemeClr val="accent1"/>
+          </a:fillRef>
+          <a:effectRef idx="2">
+            <a:schemeClr val="accent1"/>
+          </a:effectRef>
+          <a:fontRef idx="minor">
+            <a:schemeClr val="lt1"/>
+          </a:fontRef>
+        </p:style>
+        <p:txBody>
+          <a:bodyPr rtlCol="0" anchor="ctr"/>
+          <a:lstStyle/>
+          <a:p>
+            <a:pPr algn="ctr"/>
+          </a:p>
+        </p:txBody>
+      </p:sp>
+      <p:sp>
+        <p:nvSpPr>
           <p:cNvPr id="2" name="Rectangle 1"/>
           <p:cNvSpPr/>
           <p:nvPr/>
         </p:nvSpPr>
         <p:spPr>
           <a:xfrm>
-            <a:off x="0" y="0"/>
-            <a:ext cx="12191695" cy="6858000"/>
+            <a:off x="1341086" y="1028700"/>
+            <a:ext cx="9753356" cy="6858000"/>
           </a:xfrm>
           <a:prstGeom prst="rect">
             <a:avLst/>
@@ -4683,10 +5817,29 @@
           </a:fontRef>
         </p:style>
         <p:txBody>
-          <a:bodyPr rtlCol="0" anchor="ctr"/>
-          <a:lstStyle/>
-          <a:p>
-            <a:pPr algn="ctr"/>
+          <a:bodyPr rtlCol="0" anchor="ctr" wrap="square"/>
+          <a:lstStyle/>
+          <a:p>
+            <a:pPr algn="ctr">
+              <a:lnSpc>
+                <a:spcPct val="125000"/>
+              </a:lnSpc>
+              <a:spcBef>
+                <a:spcPts val="0"/>
+              </a:spcBef>
+              <a:spcAft>
+                <a:spcPts val="800"/>
+              </a:spcAft>
+            </a:pPr>
+            <a:r>
+              <a:rPr b="1" sz="3000">
+                <a:solidFill>
+                  <a:srgbClr val="EEF2FF"/>
+                </a:solidFill>
+                <a:latin typeface="JetBrains Mono"/>
+              </a:rPr>
+              <a:t>Website Structure &amp; Core Features</a:t>
+            </a:r>
           </a:p>
         </p:txBody>
       </p:sp>
@@ -4698,8 +5851,8 @@
         </p:nvSpPr>
         <p:spPr>
           <a:xfrm>
-            <a:off x="685800" y="2560320"/>
-            <a:ext cx="10515600" cy="1828800"/>
+            <a:off x="1341086" y="2560320"/>
+            <a:ext cx="9753356" cy="1828800"/>
           </a:xfrm>
           <a:prstGeom prst="rect">
             <a:avLst/>
@@ -4707,35 +5860,135 @@
           <a:noFill/>
         </p:spPr>
         <p:txBody>
+          <a:bodyPr wrap="square">
+            <a:spAutoFit/>
+          </a:bodyPr>
+          <a:lstStyle/>
+          <a:p>
+            <a:pPr>
+              <a:lnSpc>
+                <a:spcPct val="125000"/>
+              </a:lnSpc>
+              <a:spcBef>
+                <a:spcPts val="0"/>
+              </a:spcBef>
+              <a:spcAft>
+                <a:spcPts val="800"/>
+              </a:spcAft>
+              <a:defRPr sz="3600" b="1">
+                <a:solidFill>
+                  <a:srgbClr val="E3C76F"/>
+                </a:solidFill>
+              </a:defRPr>
+            </a:pPr>
+            <a:r>
+              <a:rPr b="1" sz="3000">
+                <a:solidFill>
+                  <a:srgbClr val="EEF2FF"/>
+                </a:solidFill>
+                <a:latin typeface="JetBrains Mono"/>
+              </a:rPr>
+              <a:t>Home: brand intro, featured highlights, CTA.</a:t>
+            </a:r>
+          </a:p>
+          <a:p>
+            <a:pPr>
+              <a:lnSpc>
+                <a:spcPct val="125000"/>
+              </a:lnSpc>
+              <a:spcBef>
+                <a:spcPts val="0"/>
+              </a:spcBef>
+              <a:spcAft>
+                <a:spcPts val="800"/>
+              </a:spcAft>
+            </a:pPr>
+            <a:r>
+              <a:rPr sz="1600">
+                <a:solidFill>
+                  <a:srgbClr val="CDD6F4"/>
+                </a:solidFill>
+                <a:latin typeface="JetBrains Mono"/>
+              </a:rPr>
+              <a:t>• About: brand story, context, positioning.</a:t>
+            </a:r>
+          </a:p>
+          <a:p>
+            <a:pPr>
+              <a:lnSpc>
+                <a:spcPct val="125000"/>
+              </a:lnSpc>
+              <a:spcBef>
+                <a:spcPts val="0"/>
+              </a:spcBef>
+              <a:spcAft>
+                <a:spcPts val="800"/>
+              </a:spcAft>
+            </a:pPr>
+            <a:r>
+              <a:rPr sz="1600">
+                <a:solidFill>
+                  <a:srgbClr val="CDD6F4"/>
+                </a:solidFill>
+                <a:latin typeface="JetBrains Mono"/>
+              </a:rPr>
+              <a:t>• Products: lineup details and supporting visuals.</a:t>
+            </a:r>
+          </a:p>
+          <a:p>
+            <a:pPr>
+              <a:lnSpc>
+                <a:spcPct val="125000"/>
+              </a:lnSpc>
+              <a:spcBef>
+                <a:spcPts val="0"/>
+              </a:spcBef>
+              <a:spcAft>
+                <a:spcPts val="800"/>
+              </a:spcAft>
+            </a:pPr>
+            <a:r>
+              <a:rPr sz="1600">
+                <a:solidFill>
+                  <a:srgbClr val="CDD6F4"/>
+                </a:solidFill>
+                <a:latin typeface="JetBrains Mono"/>
+              </a:rPr>
+              <a:t>• Contact: validated form, map, and social section with launch-state messaging.</a:t>
+            </a:r>
+          </a:p>
+        </p:txBody>
+      </p:sp>
+      <p:sp>
+        <p:nvSpPr>
+          <p:cNvPr id="8" name="TextBox 7"/>
+          <p:cNvSpPr txBox="1"/>
+          <p:nvPr/>
+        </p:nvSpPr>
+        <p:spPr>
+          <a:xfrm>
+            <a:off x="1097252" y="6309360"/>
+            <a:ext cx="9997189" cy="342900"/>
+          </a:xfrm>
+          <a:prstGeom prst="rect">
+            <a:avLst/>
+          </a:prstGeom>
+          <a:noFill/>
+        </p:spPr>
+        <p:txBody>
           <a:bodyPr wrap="none">
             <a:spAutoFit/>
           </a:bodyPr>
           <a:lstStyle/>
           <a:p>
-            <a:pPr>
-              <a:defRPr sz="3600" b="1">
-                <a:solidFill>
-                  <a:srgbClr val="E3C76F"/>
-                </a:solidFill>
-              </a:defRPr>
-            </a:pPr>
-            <a:r>
-              <a:t>Design &amp; UX</a:t>
-            </a:r>
-          </a:p>
-          <a:p>
-            <a:pPr>
-              <a:spcBef>
-                <a:spcPts val="1400"/>
-              </a:spcBef>
-              <a:defRPr sz="1800">
-                <a:solidFill>
-                  <a:srgbClr val="C8D2DC"/>
-                </a:solidFill>
-              </a:defRPr>
-            </a:pPr>
-            <a:r>
-              <a:t>Brand-led, user-centered</a:t>
+            <a:r>
+              <a:rPr sz="1000">
+                <a:solidFill>
+                  <a:srgbClr val="7F849C"/>
+                </a:solidFill>
+                <a:latin typeface="JetBrains Mono"/>
+              </a:rPr>
+              <a:t>AURA ENERGY  |  PRC 305 WEB DEVELOPMENT PROJECT</a:t>
             </a:r>
           </a:p>
         </p:txBody>
@@ -4760,6 +6013,180 @@
       <p:grpSpPr/>
       <p:sp>
         <p:nvSpPr>
+          <p:cNvPr id="7" name="Rounded Rectangle 6"/>
+          <p:cNvSpPr/>
+          <p:nvPr/>
+        </p:nvSpPr>
+        <p:spPr>
+          <a:xfrm>
+            <a:off x="975335" y="822960"/>
+            <a:ext cx="10484857" cy="5349240"/>
+          </a:xfrm>
+          <a:prstGeom prst="roundRect">
+            <a:avLst/>
+          </a:prstGeom>
+          <a:solidFill>
+            <a:srgbClr val="313244"/>
+          </a:solidFill>
+          <a:ln w="15240">
+            <a:solidFill>
+              <a:srgbClr val="45475A"/>
+            </a:solidFill>
+          </a:ln>
+        </p:spPr>
+        <p:style>
+          <a:lnRef idx="1">
+            <a:schemeClr val="accent1"/>
+          </a:lnRef>
+          <a:fillRef idx="3">
+            <a:schemeClr val="accent1"/>
+          </a:fillRef>
+          <a:effectRef idx="2">
+            <a:schemeClr val="accent1"/>
+          </a:effectRef>
+          <a:fontRef idx="minor">
+            <a:schemeClr val="lt1"/>
+          </a:fontRef>
+        </p:style>
+        <p:txBody>
+          <a:bodyPr rtlCol="0" anchor="ctr"/>
+          <a:lstStyle/>
+          <a:p>
+            <a:pPr algn="ctr"/>
+          </a:p>
+        </p:txBody>
+      </p:sp>
+      <p:sp>
+        <p:nvSpPr>
+          <p:cNvPr id="6" name="Rectangle 5"/>
+          <p:cNvSpPr/>
+          <p:nvPr/>
+        </p:nvSpPr>
+        <p:spPr>
+          <a:xfrm>
+            <a:off x="487667" y="548640"/>
+            <a:ext cx="73150" cy="5760720"/>
+          </a:xfrm>
+          <a:prstGeom prst="rect">
+            <a:avLst/>
+          </a:prstGeom>
+          <a:solidFill>
+            <a:srgbClr val="CBA6F7"/>
+          </a:solidFill>
+          <a:ln>
+            <a:noFill/>
+          </a:ln>
+        </p:spPr>
+        <p:style>
+          <a:lnRef idx="1">
+            <a:schemeClr val="accent1"/>
+          </a:lnRef>
+          <a:fillRef idx="3">
+            <a:schemeClr val="accent1"/>
+          </a:fillRef>
+          <a:effectRef idx="2">
+            <a:schemeClr val="accent1"/>
+          </a:effectRef>
+          <a:fontRef idx="minor">
+            <a:schemeClr val="lt1"/>
+          </a:fontRef>
+        </p:style>
+        <p:txBody>
+          <a:bodyPr rtlCol="0" anchor="ctr"/>
+          <a:lstStyle/>
+          <a:p>
+            <a:pPr algn="ctr"/>
+          </a:p>
+        </p:txBody>
+      </p:sp>
+      <p:sp>
+        <p:nvSpPr>
+          <p:cNvPr id="5" name="Rectangle 4"/>
+          <p:cNvSpPr/>
+          <p:nvPr/>
+        </p:nvSpPr>
+        <p:spPr>
+          <a:xfrm>
+            <a:off x="0" y="0"/>
+            <a:ext cx="12191695" cy="1234440"/>
+          </a:xfrm>
+          <a:prstGeom prst="rect">
+            <a:avLst/>
+          </a:prstGeom>
+          <a:solidFill>
+            <a:srgbClr val="162343"/>
+          </a:solidFill>
+          <a:ln>
+            <a:noFill/>
+          </a:ln>
+        </p:spPr>
+        <p:style>
+          <a:lnRef idx="1">
+            <a:schemeClr val="accent1"/>
+          </a:lnRef>
+          <a:fillRef idx="3">
+            <a:schemeClr val="accent1"/>
+          </a:fillRef>
+          <a:effectRef idx="2">
+            <a:schemeClr val="accent1"/>
+          </a:effectRef>
+          <a:fontRef idx="minor">
+            <a:schemeClr val="lt1"/>
+          </a:fontRef>
+        </p:style>
+        <p:txBody>
+          <a:bodyPr rtlCol="0" anchor="ctr"/>
+          <a:lstStyle/>
+          <a:p>
+            <a:pPr algn="ctr"/>
+          </a:p>
+        </p:txBody>
+      </p:sp>
+      <p:sp>
+        <p:nvSpPr>
+          <p:cNvPr id="4" name="Rectangle 3"/>
+          <p:cNvSpPr/>
+          <p:nvPr/>
+        </p:nvSpPr>
+        <p:spPr>
+          <a:xfrm>
+            <a:off x="0" y="0"/>
+            <a:ext cx="12191695" cy="6858000"/>
+          </a:xfrm>
+          <a:prstGeom prst="rect">
+            <a:avLst/>
+          </a:prstGeom>
+          <a:solidFill>
+            <a:srgbClr val="1E1E2E"/>
+          </a:solidFill>
+          <a:ln>
+            <a:noFill/>
+          </a:ln>
+        </p:spPr>
+        <p:style>
+          <a:lnRef idx="1">
+            <a:schemeClr val="accent1"/>
+          </a:lnRef>
+          <a:fillRef idx="3">
+            <a:schemeClr val="accent1"/>
+          </a:fillRef>
+          <a:effectRef idx="2">
+            <a:schemeClr val="accent1"/>
+          </a:effectRef>
+          <a:fontRef idx="minor">
+            <a:schemeClr val="lt1"/>
+          </a:fontRef>
+        </p:style>
+        <p:txBody>
+          <a:bodyPr rtlCol="0" anchor="ctr"/>
+          <a:lstStyle/>
+          <a:p>
+            <a:pPr algn="ctr"/>
+          </a:p>
+        </p:txBody>
+      </p:sp>
+      <p:sp>
+        <p:nvSpPr>
           <p:cNvPr id="2" name="Title 1"/>
           <p:cNvSpPr>
             <a:spLocks noGrp="1"/>
@@ -4768,12 +6195,25 @@
             <p:ph type="title"/>
           </p:nvPr>
         </p:nvSpPr>
-        <p:spPr/>
-        <p:txBody>
-          <a:bodyPr/>
+        <p:spPr>
+          <a:xfrm>
+            <a:off x="1341086" y="1028700"/>
+          </a:xfrm>
+        </p:spPr>
+        <p:txBody>
+          <a:bodyPr wrap="square"/>
           <a:lstStyle/>
           <a:p>
             <a:pPr>
+              <a:lnSpc>
+                <a:spcPct val="125000"/>
+              </a:lnSpc>
+              <a:spcBef>
+                <a:spcPts val="0"/>
+              </a:spcBef>
+              <a:spcAft>
+                <a:spcPts val="800"/>
+              </a:spcAft>
               <a:defRPr sz="2800" b="1">
                 <a:solidFill>
                   <a:srgbClr val="060D18"/>
@@ -4781,7 +6221,13 @@
               </a:defRPr>
             </a:pPr>
             <a:r>
-              <a:t>Design Process &amp; UI/UX</a:t>
+              <a:rPr b="1" sz="3000">
+                <a:solidFill>
+                  <a:srgbClr val="EEF2FF"/>
+                </a:solidFill>
+                <a:latin typeface="JetBrains Mono"/>
+              </a:rPr>
+              <a:t>Development Approach</a:t>
             </a:r>
           </a:p>
         </p:txBody>
@@ -4796,12 +6242,22 @@
             <p:ph idx="1"/>
           </p:nvPr>
         </p:nvSpPr>
-        <p:spPr/>
-        <p:txBody>
-          <a:bodyPr/>
+        <p:spPr>
+          <a:xfrm>
+            <a:off x="1341086" y="0"/>
+          </a:xfrm>
+        </p:spPr>
+        <p:txBody>
+          <a:bodyPr wrap="square"/>
           <a:lstStyle/>
           <a:p>
             <a:pPr>
+              <a:lnSpc>
+                <a:spcPct val="125000"/>
+              </a:lnSpc>
+              <a:spcBef>
+                <a:spcPts val="0"/>
+              </a:spcBef>
               <a:spcAft>
                 <a:spcPts val="800"/>
               </a:spcAft>
@@ -4812,19 +6268,91 @@
               </a:defRPr>
             </a:pPr>
             <a:r>
-              <a:t>Created a premium visual identity with consistent colors, typography, and spacing.</a:t>
-            </a:r>
-          </a:p>
-          <a:p>
-            <a:pPr/>
-            <a:r>
-              <a:t>Designed page flow for quick understanding: brand story to product to contact.</a:t>
-            </a:r>
-          </a:p>
-          <a:p>
-            <a:pPr/>
-            <a:r>
-              <a:t>Prioritized readability and simple actions on mobile and desktop.</a:t>
+              <a:rPr sz="1700">
+                <a:solidFill>
+                  <a:srgbClr val="CDD6F4"/>
+                </a:solidFill>
+                <a:latin typeface="JetBrains Mono"/>
+              </a:rPr>
+              <a:t>Implemented using WordPress CMS with Elementor page building workflow.</a:t>
+            </a:r>
+          </a:p>
+          <a:p>
+            <a:pPr>
+              <a:lnSpc>
+                <a:spcPct val="125000"/>
+              </a:lnSpc>
+              <a:spcBef>
+                <a:spcPts val="0"/>
+              </a:spcBef>
+              <a:spcAft>
+                <a:spcPts val="800"/>
+              </a:spcAft>
+            </a:pPr>
+            <a:r>
+              <a:rPr sz="1600">
+                <a:solidFill>
+                  <a:srgbClr val="CDD6F4"/>
+                </a:solidFill>
+                <a:latin typeface="JetBrains Mono"/>
+              </a:rPr>
+              <a:t>• Standardized page setup and styling for consistency and maintainability.</a:t>
+            </a:r>
+          </a:p>
+          <a:p>
+            <a:pPr>
+              <a:lnSpc>
+                <a:spcPct val="125000"/>
+              </a:lnSpc>
+              <a:spcBef>
+                <a:spcPts val="0"/>
+              </a:spcBef>
+              <a:spcAft>
+                <a:spcPts val="800"/>
+              </a:spcAft>
+            </a:pPr>
+            <a:r>
+              <a:rPr sz="1600">
+                <a:solidFill>
+                  <a:srgbClr val="CDD6F4"/>
+                </a:solidFill>
+                <a:latin typeface="JetBrains Mono"/>
+              </a:rPr>
+              <a:t>• Tested and refined content, responsiveness, and interaction behavior iteratively.</a:t>
+            </a:r>
+          </a:p>
+        </p:txBody>
+      </p:sp>
+      <p:sp>
+        <p:nvSpPr>
+          <p:cNvPr id="8" name="TextBox 7"/>
+          <p:cNvSpPr txBox="1"/>
+          <p:nvPr/>
+        </p:nvSpPr>
+        <p:spPr>
+          <a:xfrm>
+            <a:off x="1097252" y="6309360"/>
+            <a:ext cx="9997189" cy="342900"/>
+          </a:xfrm>
+          <a:prstGeom prst="rect">
+            <a:avLst/>
+          </a:prstGeom>
+          <a:noFill/>
+        </p:spPr>
+        <p:txBody>
+          <a:bodyPr wrap="none">
+            <a:spAutoFit/>
+          </a:bodyPr>
+          <a:lstStyle/>
+          <a:p>
+            <a:r>
+              <a:rPr sz="1000">
+                <a:solidFill>
+                  <a:srgbClr val="7F849C"/>
+                </a:solidFill>
+                <a:latin typeface="JetBrains Mono"/>
+              </a:rPr>
+              <a:t>AURA ENERGY  |  PRC 305 WEB DEVELOPMENT PROJECT</a:t>
             </a:r>
           </a:p>
         </p:txBody>
@@ -4849,6 +6377,180 @@
       <p:grpSpPr/>
       <p:sp>
         <p:nvSpPr>
+          <p:cNvPr id="7" name="Rounded Rectangle 6"/>
+          <p:cNvSpPr/>
+          <p:nvPr/>
+        </p:nvSpPr>
+        <p:spPr>
+          <a:xfrm>
+            <a:off x="975335" y="822960"/>
+            <a:ext cx="10484857" cy="5349240"/>
+          </a:xfrm>
+          <a:prstGeom prst="roundRect">
+            <a:avLst/>
+          </a:prstGeom>
+          <a:solidFill>
+            <a:srgbClr val="313244"/>
+          </a:solidFill>
+          <a:ln w="15240">
+            <a:solidFill>
+              <a:srgbClr val="45475A"/>
+            </a:solidFill>
+          </a:ln>
+        </p:spPr>
+        <p:style>
+          <a:lnRef idx="1">
+            <a:schemeClr val="accent1"/>
+          </a:lnRef>
+          <a:fillRef idx="3">
+            <a:schemeClr val="accent1"/>
+          </a:fillRef>
+          <a:effectRef idx="2">
+            <a:schemeClr val="accent1"/>
+          </a:effectRef>
+          <a:fontRef idx="minor">
+            <a:schemeClr val="lt1"/>
+          </a:fontRef>
+        </p:style>
+        <p:txBody>
+          <a:bodyPr rtlCol="0" anchor="ctr"/>
+          <a:lstStyle/>
+          <a:p>
+            <a:pPr algn="ctr"/>
+          </a:p>
+        </p:txBody>
+      </p:sp>
+      <p:sp>
+        <p:nvSpPr>
+          <p:cNvPr id="6" name="Rectangle 5"/>
+          <p:cNvSpPr/>
+          <p:nvPr/>
+        </p:nvSpPr>
+        <p:spPr>
+          <a:xfrm>
+            <a:off x="487667" y="548640"/>
+            <a:ext cx="73150" cy="5760720"/>
+          </a:xfrm>
+          <a:prstGeom prst="rect">
+            <a:avLst/>
+          </a:prstGeom>
+          <a:solidFill>
+            <a:srgbClr val="CBA6F7"/>
+          </a:solidFill>
+          <a:ln>
+            <a:noFill/>
+          </a:ln>
+        </p:spPr>
+        <p:style>
+          <a:lnRef idx="1">
+            <a:schemeClr val="accent1"/>
+          </a:lnRef>
+          <a:fillRef idx="3">
+            <a:schemeClr val="accent1"/>
+          </a:fillRef>
+          <a:effectRef idx="2">
+            <a:schemeClr val="accent1"/>
+          </a:effectRef>
+          <a:fontRef idx="minor">
+            <a:schemeClr val="lt1"/>
+          </a:fontRef>
+        </p:style>
+        <p:txBody>
+          <a:bodyPr rtlCol="0" anchor="ctr"/>
+          <a:lstStyle/>
+          <a:p>
+            <a:pPr algn="ctr"/>
+          </a:p>
+        </p:txBody>
+      </p:sp>
+      <p:sp>
+        <p:nvSpPr>
+          <p:cNvPr id="5" name="Rectangle 4"/>
+          <p:cNvSpPr/>
+          <p:nvPr/>
+        </p:nvSpPr>
+        <p:spPr>
+          <a:xfrm>
+            <a:off x="0" y="0"/>
+            <a:ext cx="12191695" cy="1234440"/>
+          </a:xfrm>
+          <a:prstGeom prst="rect">
+            <a:avLst/>
+          </a:prstGeom>
+          <a:solidFill>
+            <a:srgbClr val="162343"/>
+          </a:solidFill>
+          <a:ln>
+            <a:noFill/>
+          </a:ln>
+        </p:spPr>
+        <p:style>
+          <a:lnRef idx="1">
+            <a:schemeClr val="accent1"/>
+          </a:lnRef>
+          <a:fillRef idx="3">
+            <a:schemeClr val="accent1"/>
+          </a:fillRef>
+          <a:effectRef idx="2">
+            <a:schemeClr val="accent1"/>
+          </a:effectRef>
+          <a:fontRef idx="minor">
+            <a:schemeClr val="lt1"/>
+          </a:fontRef>
+        </p:style>
+        <p:txBody>
+          <a:bodyPr rtlCol="0" anchor="ctr"/>
+          <a:lstStyle/>
+          <a:p>
+            <a:pPr algn="ctr"/>
+          </a:p>
+        </p:txBody>
+      </p:sp>
+      <p:sp>
+        <p:nvSpPr>
+          <p:cNvPr id="4" name="Rectangle 3"/>
+          <p:cNvSpPr/>
+          <p:nvPr/>
+        </p:nvSpPr>
+        <p:spPr>
+          <a:xfrm>
+            <a:off x="0" y="0"/>
+            <a:ext cx="12191695" cy="6858000"/>
+          </a:xfrm>
+          <a:prstGeom prst="rect">
+            <a:avLst/>
+          </a:prstGeom>
+          <a:solidFill>
+            <a:srgbClr val="1E1E2E"/>
+          </a:solidFill>
+          <a:ln>
+            <a:noFill/>
+          </a:ln>
+        </p:spPr>
+        <p:style>
+          <a:lnRef idx="1">
+            <a:schemeClr val="accent1"/>
+          </a:lnRef>
+          <a:fillRef idx="3">
+            <a:schemeClr val="accent1"/>
+          </a:fillRef>
+          <a:effectRef idx="2">
+            <a:schemeClr val="accent1"/>
+          </a:effectRef>
+          <a:fontRef idx="minor">
+            <a:schemeClr val="lt1"/>
+          </a:fontRef>
+        </p:style>
+        <p:txBody>
+          <a:bodyPr rtlCol="0" anchor="ctr"/>
+          <a:lstStyle/>
+          <a:p>
+            <a:pPr algn="ctr"/>
+          </a:p>
+        </p:txBody>
+      </p:sp>
+      <p:sp>
+        <p:nvSpPr>
           <p:cNvPr id="2" name="Title 1"/>
           <p:cNvSpPr>
             <a:spLocks noGrp="1"/>
@@ -4857,12 +6559,25 @@
             <p:ph type="title"/>
           </p:nvPr>
         </p:nvSpPr>
-        <p:spPr/>
-        <p:txBody>
-          <a:bodyPr/>
+        <p:spPr>
+          <a:xfrm>
+            <a:off x="1341086" y="1028700"/>
+          </a:xfrm>
+        </p:spPr>
+        <p:txBody>
+          <a:bodyPr wrap="square"/>
           <a:lstStyle/>
           <a:p>
             <a:pPr>
+              <a:lnSpc>
+                <a:spcPct val="125000"/>
+              </a:lnSpc>
+              <a:spcBef>
+                <a:spcPts val="0"/>
+              </a:spcBef>
+              <a:spcAft>
+                <a:spcPts val="800"/>
+              </a:spcAft>
               <a:defRPr sz="2800" b="1">
                 <a:solidFill>
                   <a:srgbClr val="060D18"/>
@@ -4870,7 +6585,13 @@
               </a:defRPr>
             </a:pPr>
             <a:r>
-              <a:t>Information Architecture</a:t>
+              <a:rPr b="1" sz="3000">
+                <a:solidFill>
+                  <a:srgbClr val="EEF2FF"/>
+                </a:solidFill>
+                <a:latin typeface="JetBrains Mono"/>
+              </a:rPr>
+              <a:t>Challenges Encountered &amp; Solutions</a:t>
             </a:r>
           </a:p>
         </p:txBody>
@@ -4885,12 +6606,22 @@
             <p:ph idx="1"/>
           </p:nvPr>
         </p:nvSpPr>
-        <p:spPr/>
-        <p:txBody>
-          <a:bodyPr/>
+        <p:spPr>
+          <a:xfrm>
+            <a:off x="1341086" y="0"/>
+          </a:xfrm>
+        </p:spPr>
+        <p:txBody>
+          <a:bodyPr wrap="square"/>
           <a:lstStyle/>
           <a:p>
             <a:pPr>
+              <a:lnSpc>
+                <a:spcPct val="125000"/>
+              </a:lnSpc>
+              <a:spcBef>
+                <a:spcPts val="0"/>
+              </a:spcBef>
               <a:spcAft>
                 <a:spcPts val="800"/>
               </a:spcAft>
@@ -4901,25 +6632,113 @@
               </a:defRPr>
             </a:pPr>
             <a:r>
-              <a:t>Home: brand overview, key products, call to action.</a:t>
-            </a:r>
-          </a:p>
-          <a:p>
-            <a:pPr/>
-            <a:r>
-              <a:t>About: brand story and positioning.</a:t>
-            </a:r>
-          </a:p>
-          <a:p>
-            <a:pPr/>
-            <a:r>
-              <a:t>Products: product lineup and value highlights.</a:t>
-            </a:r>
-          </a:p>
-          <a:p>
-            <a:pPr/>
-            <a:r>
-              <a:t>Contact: form, social links, and direct communication path.</a:t>
+              <a:rPr b="1" sz="3000">
+                <a:solidFill>
+                  <a:srgbClr val="EEF2FF"/>
+                </a:solidFill>
+                <a:latin typeface="JetBrains Mono"/>
+              </a:rPr>
+              <a:t>Challenge: inconsistent rendering and missing media in some sections.</a:t>
+            </a:r>
+          </a:p>
+          <a:p>
+            <a:pPr>
+              <a:lnSpc>
+                <a:spcPct val="125000"/>
+              </a:lnSpc>
+              <a:spcBef>
+                <a:spcPts val="0"/>
+              </a:spcBef>
+              <a:spcAft>
+                <a:spcPts val="800"/>
+              </a:spcAft>
+            </a:pPr>
+            <a:r>
+              <a:rPr sz="1600">
+                <a:solidFill>
+                  <a:srgbClr val="CDD6F4"/>
+                </a:solidFill>
+                <a:latin typeface="JetBrains Mono"/>
+              </a:rPr>
+              <a:t>• Solution: corrected asset references and stabilized page rendering behavior.</a:t>
+            </a:r>
+          </a:p>
+          <a:p>
+            <a:pPr>
+              <a:lnSpc>
+                <a:spcPct val="125000"/>
+              </a:lnSpc>
+              <a:spcBef>
+                <a:spcPts val="0"/>
+              </a:spcBef>
+              <a:spcAft>
+                <a:spcPts val="800"/>
+              </a:spcAft>
+            </a:pPr>
+            <a:r>
+              <a:rPr sz="1600">
+                <a:solidFill>
+                  <a:srgbClr val="CDD6F4"/>
+                </a:solidFill>
+                <a:latin typeface="JetBrains Mono"/>
+              </a:rPr>
+              <a:t>• Challenge: contact delivery reliability from local environment.</a:t>
+            </a:r>
+          </a:p>
+          <a:p>
+            <a:pPr>
+              <a:lnSpc>
+                <a:spcPct val="125000"/>
+              </a:lnSpc>
+              <a:spcBef>
+                <a:spcPts val="0"/>
+              </a:spcBef>
+              <a:spcAft>
+                <a:spcPts val="800"/>
+              </a:spcAft>
+            </a:pPr>
+            <a:r>
+              <a:rPr sz="1600">
+                <a:solidFill>
+                  <a:srgbClr val="CDD6F4"/>
+                </a:solidFill>
+                <a:latin typeface="JetBrains Mono"/>
+              </a:rPr>
+              <a:t>• Solution: configured SMTP and verified successful form submissions.</a:t>
+            </a:r>
+          </a:p>
+        </p:txBody>
+      </p:sp>
+      <p:sp>
+        <p:nvSpPr>
+          <p:cNvPr id="8" name="TextBox 7"/>
+          <p:cNvSpPr txBox="1"/>
+          <p:nvPr/>
+        </p:nvSpPr>
+        <p:spPr>
+          <a:xfrm>
+            <a:off x="1097252" y="6309360"/>
+            <a:ext cx="9997189" cy="342900"/>
+          </a:xfrm>
+          <a:prstGeom prst="rect">
+            <a:avLst/>
+          </a:prstGeom>
+          <a:noFill/>
+        </p:spPr>
+        <p:txBody>
+          <a:bodyPr wrap="none">
+            <a:spAutoFit/>
+          </a:bodyPr>
+          <a:lstStyle/>
+          <a:p>
+            <a:r>
+              <a:rPr sz="1000">
+                <a:solidFill>
+                  <a:srgbClr val="7F849C"/>
+                </a:solidFill>
+                <a:latin typeface="JetBrains Mono"/>
+              </a:rPr>
+              <a:t>AURA ENERGY  |  PRC 305 WEB DEVELOPMENT PROJECT</a:t>
             </a:r>
           </a:p>
         </p:txBody>
@@ -4944,14 +6763,188 @@
       <p:grpSpPr/>
       <p:sp>
         <p:nvSpPr>
+          <p:cNvPr id="7" name="Rounded Rectangle 6"/>
+          <p:cNvSpPr/>
+          <p:nvPr/>
+        </p:nvSpPr>
+        <p:spPr>
+          <a:xfrm>
+            <a:off x="975335" y="822960"/>
+            <a:ext cx="10484857" cy="5349240"/>
+          </a:xfrm>
+          <a:prstGeom prst="roundRect">
+            <a:avLst/>
+          </a:prstGeom>
+          <a:solidFill>
+            <a:srgbClr val="313244"/>
+          </a:solidFill>
+          <a:ln w="15240">
+            <a:solidFill>
+              <a:srgbClr val="45475A"/>
+            </a:solidFill>
+          </a:ln>
+        </p:spPr>
+        <p:style>
+          <a:lnRef idx="1">
+            <a:schemeClr val="accent1"/>
+          </a:lnRef>
+          <a:fillRef idx="3">
+            <a:schemeClr val="accent1"/>
+          </a:fillRef>
+          <a:effectRef idx="2">
+            <a:schemeClr val="accent1"/>
+          </a:effectRef>
+          <a:fontRef idx="minor">
+            <a:schemeClr val="lt1"/>
+          </a:fontRef>
+        </p:style>
+        <p:txBody>
+          <a:bodyPr rtlCol="0" anchor="ctr"/>
+          <a:lstStyle/>
+          <a:p>
+            <a:pPr algn="ctr"/>
+          </a:p>
+        </p:txBody>
+      </p:sp>
+      <p:sp>
+        <p:nvSpPr>
+          <p:cNvPr id="6" name="Rectangle 5"/>
+          <p:cNvSpPr/>
+          <p:nvPr/>
+        </p:nvSpPr>
+        <p:spPr>
+          <a:xfrm>
+            <a:off x="487667" y="548640"/>
+            <a:ext cx="73150" cy="5760720"/>
+          </a:xfrm>
+          <a:prstGeom prst="rect">
+            <a:avLst/>
+          </a:prstGeom>
+          <a:solidFill>
+            <a:srgbClr val="CBA6F7"/>
+          </a:solidFill>
+          <a:ln>
+            <a:noFill/>
+          </a:ln>
+        </p:spPr>
+        <p:style>
+          <a:lnRef idx="1">
+            <a:schemeClr val="accent1"/>
+          </a:lnRef>
+          <a:fillRef idx="3">
+            <a:schemeClr val="accent1"/>
+          </a:fillRef>
+          <a:effectRef idx="2">
+            <a:schemeClr val="accent1"/>
+          </a:effectRef>
+          <a:fontRef idx="minor">
+            <a:schemeClr val="lt1"/>
+          </a:fontRef>
+        </p:style>
+        <p:txBody>
+          <a:bodyPr rtlCol="0" anchor="ctr"/>
+          <a:lstStyle/>
+          <a:p>
+            <a:pPr algn="ctr"/>
+          </a:p>
+        </p:txBody>
+      </p:sp>
+      <p:sp>
+        <p:nvSpPr>
+          <p:cNvPr id="5" name="Rectangle 4"/>
+          <p:cNvSpPr/>
+          <p:nvPr/>
+        </p:nvSpPr>
+        <p:spPr>
+          <a:xfrm>
+            <a:off x="0" y="0"/>
+            <a:ext cx="12191695" cy="1234440"/>
+          </a:xfrm>
+          <a:prstGeom prst="rect">
+            <a:avLst/>
+          </a:prstGeom>
+          <a:solidFill>
+            <a:srgbClr val="162343"/>
+          </a:solidFill>
+          <a:ln>
+            <a:noFill/>
+          </a:ln>
+        </p:spPr>
+        <p:style>
+          <a:lnRef idx="1">
+            <a:schemeClr val="accent1"/>
+          </a:lnRef>
+          <a:fillRef idx="3">
+            <a:schemeClr val="accent1"/>
+          </a:fillRef>
+          <a:effectRef idx="2">
+            <a:schemeClr val="accent1"/>
+          </a:effectRef>
+          <a:fontRef idx="minor">
+            <a:schemeClr val="lt1"/>
+          </a:fontRef>
+        </p:style>
+        <p:txBody>
+          <a:bodyPr rtlCol="0" anchor="ctr"/>
+          <a:lstStyle/>
+          <a:p>
+            <a:pPr algn="ctr"/>
+          </a:p>
+        </p:txBody>
+      </p:sp>
+      <p:sp>
+        <p:nvSpPr>
+          <p:cNvPr id="4" name="Rectangle 3"/>
+          <p:cNvSpPr/>
+          <p:nvPr/>
+        </p:nvSpPr>
+        <p:spPr>
+          <a:xfrm>
+            <a:off x="0" y="0"/>
+            <a:ext cx="12191695" cy="6858000"/>
+          </a:xfrm>
+          <a:prstGeom prst="rect">
+            <a:avLst/>
+          </a:prstGeom>
+          <a:solidFill>
+            <a:srgbClr val="1E1E2E"/>
+          </a:solidFill>
+          <a:ln>
+            <a:noFill/>
+          </a:ln>
+        </p:spPr>
+        <p:style>
+          <a:lnRef idx="1">
+            <a:schemeClr val="accent1"/>
+          </a:lnRef>
+          <a:fillRef idx="3">
+            <a:schemeClr val="accent1"/>
+          </a:fillRef>
+          <a:effectRef idx="2">
+            <a:schemeClr val="accent1"/>
+          </a:effectRef>
+          <a:fontRef idx="minor">
+            <a:schemeClr val="lt1"/>
+          </a:fontRef>
+        </p:style>
+        <p:txBody>
+          <a:bodyPr rtlCol="0" anchor="ctr"/>
+          <a:lstStyle/>
+          <a:p>
+            <a:pPr algn="ctr"/>
+          </a:p>
+        </p:txBody>
+      </p:sp>
+      <p:sp>
+        <p:nvSpPr>
           <p:cNvPr id="2" name="Rectangle 1"/>
           <p:cNvSpPr/>
           <p:nvPr/>
         </p:nvSpPr>
         <p:spPr>
           <a:xfrm>
-            <a:off x="0" y="0"/>
-            <a:ext cx="12191695" cy="6858000"/>
+            <a:off x="1341086" y="1028700"/>
+            <a:ext cx="9753356" cy="6858000"/>
           </a:xfrm>
           <a:prstGeom prst="rect">
             <a:avLst/>
@@ -4978,10 +6971,29 @@
           </a:fontRef>
         </p:style>
         <p:txBody>
-          <a:bodyPr rtlCol="0" anchor="ctr"/>
-          <a:lstStyle/>
-          <a:p>
-            <a:pPr algn="ctr"/>
+          <a:bodyPr rtlCol="0" anchor="ctr" wrap="square"/>
+          <a:lstStyle/>
+          <a:p>
+            <a:pPr algn="ctr">
+              <a:lnSpc>
+                <a:spcPct val="125000"/>
+              </a:lnSpc>
+              <a:spcBef>
+                <a:spcPts val="0"/>
+              </a:spcBef>
+              <a:spcAft>
+                <a:spcPts val="800"/>
+              </a:spcAft>
+            </a:pPr>
+            <a:r>
+              <a:rPr b="1" sz="3000">
+                <a:solidFill>
+                  <a:srgbClr val="EEF2FF"/>
+                </a:solidFill>
+                <a:latin typeface="JetBrains Mono"/>
+              </a:rPr>
+              <a:t>Live Demonstration</a:t>
+            </a:r>
           </a:p>
         </p:txBody>
       </p:sp>
@@ -4993,8 +7005,8 @@
         </p:nvSpPr>
         <p:spPr>
           <a:xfrm>
-            <a:off x="685800" y="2560320"/>
-            <a:ext cx="10515600" cy="1828800"/>
+            <a:off x="1341086" y="2560320"/>
+            <a:ext cx="9753356" cy="1828800"/>
           </a:xfrm>
           <a:prstGeom prst="rect">
             <a:avLst/>
@@ -5002,35 +7014,157 @@
           <a:noFill/>
         </p:spPr>
         <p:txBody>
+          <a:bodyPr wrap="square">
+            <a:spAutoFit/>
+          </a:bodyPr>
+          <a:lstStyle/>
+          <a:p>
+            <a:pPr>
+              <a:lnSpc>
+                <a:spcPct val="125000"/>
+              </a:lnSpc>
+              <a:spcBef>
+                <a:spcPts val="0"/>
+              </a:spcBef>
+              <a:spcAft>
+                <a:spcPts val="800"/>
+              </a:spcAft>
+              <a:defRPr sz="3600" b="1">
+                <a:solidFill>
+                  <a:srgbClr val="E3C76F"/>
+                </a:solidFill>
+              </a:defRPr>
+            </a:pPr>
+            <a:r>
+              <a:rPr sz="1700">
+                <a:solidFill>
+                  <a:srgbClr val="CDD6F4"/>
+                </a:solidFill>
+                <a:latin typeface="JetBrains Mono"/>
+              </a:rPr>
+              <a:t>Open live website: https://08e8-41-90-185-182.ngrok-free.app/wordpress</a:t>
+            </a:r>
+          </a:p>
+          <a:p>
+            <a:pPr>
+              <a:lnSpc>
+                <a:spcPct val="125000"/>
+              </a:lnSpc>
+              <a:spcBef>
+                <a:spcPts val="0"/>
+              </a:spcBef>
+              <a:spcAft>
+                <a:spcPts val="800"/>
+              </a:spcAft>
+            </a:pPr>
+            <a:r>
+              <a:rPr sz="1600">
+                <a:solidFill>
+                  <a:srgbClr val="CDD6F4"/>
+                </a:solidFill>
+                <a:latin typeface="JetBrains Mono"/>
+              </a:rPr>
+              <a:t>• Navigate Home, About, Products, Contact.</a:t>
+            </a:r>
+          </a:p>
+          <a:p>
+            <a:pPr>
+              <a:lnSpc>
+                <a:spcPct val="125000"/>
+              </a:lnSpc>
+              <a:spcBef>
+                <a:spcPts val="0"/>
+              </a:spcBef>
+              <a:spcAft>
+                <a:spcPts val="800"/>
+              </a:spcAft>
+            </a:pPr>
+            <a:r>
+              <a:rPr sz="1600">
+                <a:solidFill>
+                  <a:srgbClr val="CDD6F4"/>
+                </a:solidFill>
+                <a:latin typeface="JetBrains Mono"/>
+              </a:rPr>
+              <a:t>• Show responsive behavior (desktop + mobile view).</a:t>
+            </a:r>
+          </a:p>
+          <a:p>
+            <a:pPr>
+              <a:lnSpc>
+                <a:spcPct val="125000"/>
+              </a:lnSpc>
+              <a:spcBef>
+                <a:spcPts val="0"/>
+              </a:spcBef>
+              <a:spcAft>
+                <a:spcPts val="800"/>
+              </a:spcAft>
+            </a:pPr>
+            <a:r>
+              <a:rPr sz="1600">
+                <a:solidFill>
+                  <a:srgbClr val="CDD6F4"/>
+                </a:solidFill>
+                <a:latin typeface="JetBrains Mono"/>
+              </a:rPr>
+              <a:t>• Run contact form tests: empty validation, invalid email, valid submit success.</a:t>
+            </a:r>
+          </a:p>
+          <a:p>
+            <a:pPr>
+              <a:lnSpc>
+                <a:spcPct val="125000"/>
+              </a:lnSpc>
+              <a:spcBef>
+                <a:spcPts val="0"/>
+              </a:spcBef>
+              <a:spcAft>
+                <a:spcPts val="800"/>
+              </a:spcAft>
+            </a:pPr>
+            <a:r>
+              <a:rPr sz="1600">
+                <a:solidFill>
+                  <a:srgbClr val="CDD6F4"/>
+                </a:solidFill>
+                <a:latin typeface="JetBrains Mono"/>
+              </a:rPr>
+              <a:t>• Show evidence: form entry captured in admin and email notification received.</a:t>
+            </a:r>
+          </a:p>
+        </p:txBody>
+      </p:sp>
+      <p:sp>
+        <p:nvSpPr>
+          <p:cNvPr id="8" name="TextBox 7"/>
+          <p:cNvSpPr txBox="1"/>
+          <p:nvPr/>
+        </p:nvSpPr>
+        <p:spPr>
+          <a:xfrm>
+            <a:off x="1097252" y="6309360"/>
+            <a:ext cx="9997189" cy="342900"/>
+          </a:xfrm>
+          <a:prstGeom prst="rect">
+            <a:avLst/>
+          </a:prstGeom>
+          <a:noFill/>
+        </p:spPr>
+        <p:txBody>
           <a:bodyPr wrap="none">
             <a:spAutoFit/>
           </a:bodyPr>
           <a:lstStyle/>
           <a:p>
-            <a:pPr>
-              <a:defRPr sz="3600" b="1">
-                <a:solidFill>
-                  <a:srgbClr val="E3C76F"/>
-                </a:solidFill>
-              </a:defRPr>
-            </a:pPr>
-            <a:r>
-              <a:t>Technology</a:t>
-            </a:r>
-          </a:p>
-          <a:p>
-            <a:pPr>
-              <a:spcBef>
-                <a:spcPts val="1400"/>
-              </a:spcBef>
-              <a:defRPr sz="1800">
-                <a:solidFill>
-                  <a:srgbClr val="C8D2DC"/>
-                </a:solidFill>
-              </a:defRPr>
-            </a:pPr>
-            <a:r>
-              <a:t>Stack &amp; workflow</a:t>
+            <a:r>
+              <a:rPr sz="1000">
+                <a:solidFill>
+                  <a:srgbClr val="7F849C"/>
+                </a:solidFill>
+                <a:latin typeface="JetBrains Mono"/>
+              </a:rPr>
+              <a:t>AURA ENERGY  |  PRC 305 WEB DEVELOPMENT PROJECT</a:t>
             </a:r>
           </a:p>
         </p:txBody>

</xml_diff>